<commit_message>
docs(slides): refresh ML presentation and narration
</commit_message>
<xml_diff>
--- a/reports/slides/ITviec_Sentiment_Analysis.pptx
+++ b/reports/slides/ITviec_Sentiment_Analysis.pptx
@@ -2,27 +2,27 @@
 <file path=ppt/presentation.xml><?xml version="1.0" encoding="utf-8"?>
 <p:presentation xmlns:p="http://schemas.openxmlformats.org/presentationml/2006/main">
   <p:sldMasterIdLst>
-    <p:sldMasterId xmlns:r="http://schemas.openxmlformats.org/officeDocument/2006/relationships" id="2147483648" r:id="R9ca045bcc3b74634"/>
+    <p:sldMasterId xmlns:r="http://schemas.openxmlformats.org/officeDocument/2006/relationships" id="2147483648" r:id="Rd35db0d22386409d"/>
   </p:sldMasterIdLst>
   <p:notesMasterIdLst>
-    <p:notesMasterId xmlns:r="http://schemas.openxmlformats.org/officeDocument/2006/relationships" r:id="R16b124bf7d544c74"/>
+    <p:notesMasterId xmlns:r="http://schemas.openxmlformats.org/officeDocument/2006/relationships" r:id="Rf9ab59980ceb4569"/>
   </p:notesMasterIdLst>
   <p:sldIdLst>
-    <p:sldId xmlns:r="http://schemas.openxmlformats.org/officeDocument/2006/relationships" id="256" r:id="R2cf7305f57b84e09"/>
-    <p:sldId xmlns:r="http://schemas.openxmlformats.org/officeDocument/2006/relationships" id="257" r:id="R8ac38a9ec02b4296"/>
-    <p:sldId xmlns:r="http://schemas.openxmlformats.org/officeDocument/2006/relationships" id="258" r:id="R1bba0e616c624eda"/>
-    <p:sldId xmlns:r="http://schemas.openxmlformats.org/officeDocument/2006/relationships" id="259" r:id="R2cb25ae990404526"/>
-    <p:sldId xmlns:r="http://schemas.openxmlformats.org/officeDocument/2006/relationships" id="260" r:id="R70c4bd89d97048e5"/>
-    <p:sldId xmlns:r="http://schemas.openxmlformats.org/officeDocument/2006/relationships" id="261" r:id="Rd07bad9cf40f46e0"/>
-    <p:sldId xmlns:r="http://schemas.openxmlformats.org/officeDocument/2006/relationships" id="262" r:id="Rd4c3e423f44f46d0"/>
-    <p:sldId xmlns:r="http://schemas.openxmlformats.org/officeDocument/2006/relationships" id="263" r:id="Rca170baab35249e4"/>
-    <p:sldId xmlns:r="http://schemas.openxmlformats.org/officeDocument/2006/relationships" id="264" r:id="R9a7dc6d346fe437b"/>
-    <p:sldId xmlns:r="http://schemas.openxmlformats.org/officeDocument/2006/relationships" id="265" r:id="Rf36b8e34bc0843be"/>
-    <p:sldId xmlns:r="http://schemas.openxmlformats.org/officeDocument/2006/relationships" id="266" r:id="Rfdba7407daed41db"/>
-    <p:sldId xmlns:r="http://schemas.openxmlformats.org/officeDocument/2006/relationships" id="267" r:id="R45e98c462c6f44e3"/>
-    <p:sldId xmlns:r="http://schemas.openxmlformats.org/officeDocument/2006/relationships" id="268" r:id="R3af3cbe22e7b4ce0"/>
-    <p:sldId xmlns:r="http://schemas.openxmlformats.org/officeDocument/2006/relationships" id="269" r:id="R7c1f287fc0a84245"/>
-    <p:sldId xmlns:r="http://schemas.openxmlformats.org/officeDocument/2006/relationships" id="270" r:id="R78dd6b8213bf4683"/>
+    <p:sldId xmlns:r="http://schemas.openxmlformats.org/officeDocument/2006/relationships" id="256" r:id="Ra35b33c4dafd4abc"/>
+    <p:sldId xmlns:r="http://schemas.openxmlformats.org/officeDocument/2006/relationships" id="257" r:id="Rad07964a62ea4fc0"/>
+    <p:sldId xmlns:r="http://schemas.openxmlformats.org/officeDocument/2006/relationships" id="258" r:id="R598d8865e61d49ac"/>
+    <p:sldId xmlns:r="http://schemas.openxmlformats.org/officeDocument/2006/relationships" id="259" r:id="R3dc5a626c00c43c5"/>
+    <p:sldId xmlns:r="http://schemas.openxmlformats.org/officeDocument/2006/relationships" id="260" r:id="R2d0667cffa8944fc"/>
+    <p:sldId xmlns:r="http://schemas.openxmlformats.org/officeDocument/2006/relationships" id="261" r:id="Rc7b01f04705545c8"/>
+    <p:sldId xmlns:r="http://schemas.openxmlformats.org/officeDocument/2006/relationships" id="262" r:id="R484a9f7f64534a4b"/>
+    <p:sldId xmlns:r="http://schemas.openxmlformats.org/officeDocument/2006/relationships" id="263" r:id="Ra00048383c1544f2"/>
+    <p:sldId xmlns:r="http://schemas.openxmlformats.org/officeDocument/2006/relationships" id="264" r:id="Ra15fcace237049f3"/>
+    <p:sldId xmlns:r="http://schemas.openxmlformats.org/officeDocument/2006/relationships" id="265" r:id="R385a2abad5514d2f"/>
+    <p:sldId xmlns:r="http://schemas.openxmlformats.org/officeDocument/2006/relationships" id="266" r:id="R951c19ce46ef4a4f"/>
+    <p:sldId xmlns:r="http://schemas.openxmlformats.org/officeDocument/2006/relationships" id="267" r:id="Ra5f000aea2534e3a"/>
+    <p:sldId xmlns:r="http://schemas.openxmlformats.org/officeDocument/2006/relationships" id="268" r:id="Rb950c3ac41ae4615"/>
+    <p:sldId xmlns:r="http://schemas.openxmlformats.org/officeDocument/2006/relationships" id="269" r:id="Re819076286cd4919"/>
+    <p:sldId xmlns:r="http://schemas.openxmlformats.org/officeDocument/2006/relationships" id="270" r:id="Rf60d6fe5ec9f411b"/>
   </p:sldIdLst>
   <p:sldSz cx="12192000" cy="6858000"/>
   <p:notesSz cx="6858000" cy="9144000"/>
@@ -559,6 +559,14 @@
               <a:t>Nguồn nội bộ: reports/evaluation/error_analysis_15_samples.csv; reports/tv4_model_evaluation_error_analysis.md</a:t>
             </a:r>
           </a:p>
+          <a:p xmlns:a="http://schemas.openxmlformats.org/drawingml/2006/main">
+            <a:r>
+              <a:t>
+[Sources]
+reports/evaluation/retrained_v2/error_examples_15.csv; all_final_test_errors.csv
+[/Sources]</a:t>
+            </a:r>
+          </a:p>
         </p:txBody>
       </p:sp>
       <p:sp>
@@ -729,6 +737,14 @@
               <a:t>Nguồn nội bộ: src/tv4_analysis.py; app_pages/predict.py</a:t>
             </a:r>
           </a:p>
+          <a:p xmlns:a="http://schemas.openxmlformats.org/drawingml/2006/main">
+            <a:r>
+              <a:t>
+[Sources]
+current predict_review() output for the slide 4 example
+[/Sources]</a:t>
+            </a:r>
+          </a:p>
         </p:txBody>
       </p:sp>
       <p:sp>
@@ -814,6 +830,14 @@
               <a:t>Nguồn nội bộ: reports/tv4_model_evaluation_error_analysis.md; reports/modeling_hyperparameter_tuning.md</a:t>
             </a:r>
           </a:p>
+          <a:p xmlns:a="http://schemas.openxmlformats.org/drawingml/2006/main">
+            <a:r>
+              <a:t>
+[Sources]
+models/retrained_v2/training_audit.json; reports/evaluation/retrained_v2/final_test_snapshot.json
+[/Sources]</a:t>
+            </a:r>
+          </a:p>
         </p:txBody>
       </p:sp>
       <p:sp>
@@ -899,6 +923,14 @@
               <a:t>Nguồn nội bộ: README.md; reports/final_report_outline.md</a:t>
             </a:r>
           </a:p>
+          <a:p xmlns:a="http://schemas.openxmlformats.org/drawingml/2006/main">
+            <a:r>
+              <a:t>
+[Sources]
+scripts/retrain_sentiment_after_preprocessing.py; reports/retrained_v2_evaluation.md
+[/Sources]</a:t>
+            </a:r>
+          </a:p>
         </p:txBody>
       </p:sp>
       <p:sp>
@@ -1154,6 +1186,14 @@
               <a:t>Nguồn nội bộ: README.md mục 2.4; models/artifact_manifest.json</a:t>
             </a:r>
           </a:p>
+          <a:p xmlns:a="http://schemas.openxmlformats.org/drawingml/2006/main">
+            <a:r>
+              <a:t>
+[Sources]
+reports/evaluation/retrained_v2/final_test_snapshot.json
+[/Sources]</a:t>
+            </a:r>
+          </a:p>
         </p:txBody>
       </p:sp>
       <p:sp>
@@ -1239,6 +1279,14 @@
               <a:t>Nguồn nội bộ: src/preprocessing.py; src/tv4_analysis.py</a:t>
             </a:r>
           </a:p>
+          <a:p xmlns:a="http://schemas.openxmlformats.org/drawingml/2006/main">
+            <a:r>
+              <a:t>
+[Sources]
+src/preprocessing.py; current predict_review() output
+[/Sources]</a:t>
+            </a:r>
+          </a:p>
         </p:txBody>
       </p:sp>
       <p:sp>
@@ -1579,6 +1627,14 @@
               <a:t>Nguồn nội bộ: reports/evaluation/model_ranking_cv.csv; reports/modeling_hyperparameter_tuning.md mục 5.1</a:t>
             </a:r>
           </a:p>
+          <a:p xmlns:a="http://schemas.openxmlformats.org/drawingml/2006/main">
+            <a:r>
+              <a:t>
+[Sources]
+reports/evaluation/model_ranking_cv.csv; models/retrained_v2/training_audit.json
+[/Sources]</a:t>
+            </a:r>
+          </a:p>
         </p:txBody>
       </p:sp>
       <p:sp>
@@ -1662,6 +1718,14 @@
           <a:p xmlns:a="http://schemas.openxmlformats.org/drawingml/2006/main">
             <a:r>
               <a:t>Nguồn nội bộ: reports/evaluation/final_test_metrics.csv; reports/evaluation/confusion_matrix.csv; reports/evaluation/final_test_per_class.csv</a:t>
+            </a:r>
+          </a:p>
+          <a:p xmlns:a="http://schemas.openxmlformats.org/drawingml/2006/main">
+            <a:r>
+              <a:t>
+[Sources]
+reports/evaluation/retrained_v2/final_test_snapshot.json; final_test_per_class.csv; confusion_matrix.csv
+[/Sources]</a:t>
             </a:r>
           </a:p>
         </p:txBody>
@@ -1729,7 +1793,7 @@
   </p:cSld>
   <p:clrMap bg1="lt1" tx1="dk1" bg2="lt2" tx2="dk2" accent1="accent1" accent2="accent2" accent3="accent3" accent4="accent4" accent5="accent5" accent6="accent6" hlink="hlink" folHlink="folHlink"/>
   <p:sldLayoutIdLst>
-    <p:sldLayoutId xmlns:r="http://schemas.openxmlformats.org/officeDocument/2006/relationships" id="2147483649" r:id="R3be85fd3db5f4c13"/>
+    <p:sldLayoutId xmlns:r="http://schemas.openxmlformats.org/officeDocument/2006/relationships" id="2147483649" r:id="Rd49a1574ff894178"/>
   </p:sldLayoutIdLst>
   <p:txStyles>
     <p:titleStyle>
@@ -2415,6 +2479,9 @@
           </a:p>
         </c:txPr>
         <c:crossAx val="48672768"/>
+        <c:lblAlgn val="ctr"/>
+        <c:lblOffset val="100"/>
+        <c:noMultiLvlLbl val="0"/>
       </c:catAx>
       <c:valAx>
         <c:axId val="48672768"/>
@@ -2623,6 +2690,9 @@
           </a:p>
         </c:txPr>
         <c:crossAx val="48672768"/>
+        <c:lblAlgn val="ctr"/>
+        <c:lblOffset val="100"/>
+        <c:noMultiLvlLbl val="0"/>
       </c:catAx>
       <c:valAx>
         <c:axId val="48672768"/>
@@ -2826,6 +2896,9 @@
           </a:p>
         </c:txPr>
         <c:crossAx val="48672768"/>
+        <c:lblAlgn val="ctr"/>
+        <c:lblOffset val="100"/>
+        <c:noMultiLvlLbl val="0"/>
       </c:catAx>
       <c:valAx>
         <c:axId val="48672768"/>
@@ -2940,13 +3013,13 @@
               <c:formatCode>General</c:formatCode>
               <c:ptCount val="3"/>
               <c:pt idx="0">
-                <c:v>38.06</c:v>
+                <c:v>39.1</c:v>
               </c:pt>
               <c:pt idx="1">
-                <c:v>47.95</c:v>
+                <c:v>47.8</c:v>
               </c:pt>
               <c:pt idx="2">
-                <c:v>85.39</c:v>
+                <c:v>86.02</c:v>
               </c:pt>
             </c:numLit>
           </c:val>
@@ -3026,6 +3099,9 @@
           </a:p>
         </c:txPr>
         <c:crossAx val="48672768"/>
+        <c:lblAlgn val="ctr"/>
+        <c:lblOffset val="100"/>
+        <c:noMultiLvlLbl val="0"/>
       </c:catAx>
       <c:valAx>
         <c:axId val="48672768"/>
@@ -3314,6 +3390,9 @@
           </a:p>
         </c:txPr>
         <c:crossAx val="48672768"/>
+        <c:lblAlgn val="ctr"/>
+        <c:lblOffset val="100"/>
+        <c:noMultiLvlLbl val="0"/>
       </c:catAx>
       <c:valAx>
         <c:axId val="48672768"/>
@@ -3407,7 +3486,7 @@
           <c:idx val="0"/>
           <c:order val="0"/>
           <c:tx>
-            <c:v>TF-IDF (%)</c:v>
+            <c:v>TF-IDF (×100)</c:v>
           </c:tx>
           <c:spPr>
             <a:solidFill xmlns:a="http://schemas.openxmlformats.org/drawingml/2006/main">
@@ -3418,19 +3497,19 @@
             <c:strLit>
               <c:ptCount val="5"/>
               <c:pt idx="0">
-                <c:v>xuyên</c:v>
+                <c:v>không lương</c:v>
               </c:pt>
               <c:pt idx="1">
-                <c:v>lý</c:v>
+                <c:v>thường_xuyên</c:v>
               </c:pt>
               <c:pt idx="2">
-                <c:v>không lương</c:v>
+                <c:v>thiếu</c:v>
               </c:pt>
               <c:pt idx="3">
-                <c:v>lương</c:v>
+                <c:v>minh_bạch</c:v>
               </c:pt>
               <c:pt idx="4">
-                <c:v>không</c:v>
+                <c:v>thường_xuyên ot</c:v>
               </c:pt>
             </c:strLit>
           </c:cat>
@@ -3439,19 +3518,19 @@
               <c:formatCode>General</c:formatCode>
               <c:ptCount val="5"/>
               <c:pt idx="0">
-                <c:v>61.5</c:v>
+                <c:v>30.6</c:v>
               </c:pt>
               <c:pt idx="1">
-                <c:v>60.6</c:v>
+                <c:v>31</c:v>
               </c:pt>
               <c:pt idx="2">
-                <c:v>38.4</c:v>
+                <c:v>33.9</c:v>
               </c:pt>
               <c:pt idx="3">
-                <c:v>29.6</c:v>
+                <c:v>37.3</c:v>
               </c:pt>
               <c:pt idx="4">
-                <c:v>13.8</c:v>
+                <c:v>44.6</c:v>
               </c:pt>
             </c:numLit>
           </c:val>
@@ -3531,6 +3610,9 @@
           </a:p>
         </c:txPr>
         <c:crossAx val="48672768"/>
+        <c:lblAlgn val="ctr"/>
+        <c:lblOffset val="100"/>
+        <c:noMultiLvlLbl val="0"/>
       </c:catAx>
       <c:valAx>
         <c:axId val="48672768"/>
@@ -3672,6 +3754,7 @@
           <a:lstStyle xmlns:a="http://schemas.openxmlformats.org/drawingml/2006/main"/>
           <a:p xmlns:a="http://schemas.openxmlformats.org/drawingml/2006/main">
             <a:pPr algn="l">
+              <a:buNone/>
               <a:defRPr sz="1200" b="1">
                 <a:solidFill>
                   <a:srgbClr val="78A7FF"/>
@@ -3729,6 +3812,7 @@
           <a:lstStyle xmlns:a="http://schemas.openxmlformats.org/drawingml/2006/main"/>
           <a:p xmlns:a="http://schemas.openxmlformats.org/drawingml/2006/main">
             <a:pPr algn="l">
+              <a:buNone/>
               <a:defRPr sz="3750" b="1">
                 <a:solidFill>
                   <a:srgbClr val="F4F7FB"/>
@@ -3752,6 +3836,7 @@
           </a:p>
           <a:p xmlns:a="http://schemas.openxmlformats.org/drawingml/2006/main">
             <a:pPr algn="l">
+              <a:buNone/>
               <a:defRPr sz="3750" b="1">
                 <a:solidFill>
                   <a:srgbClr val="F4F7FB"/>
@@ -3809,6 +3894,7 @@
           <a:lstStyle xmlns:a="http://schemas.openxmlformats.org/drawingml/2006/main"/>
           <a:p xmlns:a="http://schemas.openxmlformats.org/drawingml/2006/main">
             <a:pPr algn="l">
+              <a:buNone/>
               <a:defRPr sz="1725" b="0">
                 <a:solidFill>
                   <a:srgbClr val="A7B3C4"/>
@@ -3897,6 +3983,7 @@
           <a:lstStyle xmlns:a="http://schemas.openxmlformats.org/drawingml/2006/main"/>
           <a:p xmlns:a="http://schemas.openxmlformats.org/drawingml/2006/main">
             <a:pPr algn="l">
+              <a:buNone/>
               <a:defRPr sz="975" b="1">
                 <a:solidFill>
                   <a:srgbClr val="78A7FF"/>
@@ -3954,6 +4041,7 @@
           <a:lstStyle xmlns:a="http://schemas.openxmlformats.org/drawingml/2006/main"/>
           <a:p xmlns:a="http://schemas.openxmlformats.org/drawingml/2006/main">
             <a:pPr algn="l">
+              <a:buNone/>
               <a:defRPr sz="1950" b="1">
                 <a:solidFill>
                   <a:srgbClr val="F4F7FB"/>
@@ -4011,6 +4099,7 @@
           <a:lstStyle xmlns:a="http://schemas.openxmlformats.org/drawingml/2006/main"/>
           <a:p xmlns:a="http://schemas.openxmlformats.org/drawingml/2006/main">
             <a:pPr algn="l">
+              <a:buNone/>
               <a:defRPr sz="1425" b="0">
                 <a:solidFill>
                   <a:srgbClr val="A7B3C4"/>
@@ -4068,6 +4157,7 @@
           <a:lstStyle xmlns:a="http://schemas.openxmlformats.org/drawingml/2006/main"/>
           <a:p xmlns:a="http://schemas.openxmlformats.org/drawingml/2006/main">
             <a:pPr algn="l">
+              <a:buNone/>
               <a:defRPr sz="975" b="1">
                 <a:solidFill>
                   <a:srgbClr val="78A7FF"/>
@@ -4125,6 +4215,7 @@
           <a:lstStyle xmlns:a="http://schemas.openxmlformats.org/drawingml/2006/main"/>
           <a:p xmlns:a="http://schemas.openxmlformats.org/drawingml/2006/main">
             <a:pPr algn="l">
+              <a:buNone/>
               <a:defRPr sz="1275" b="1">
                 <a:solidFill>
                   <a:srgbClr val="F4F7FB"/>
@@ -4150,17 +4241,17 @@
       </p:sp>
       <p:pic>
         <p:nvPicPr>
-          <p:cNvPr id="23" name=""/>
+          <p:cNvPr id="25" name=""/>
           <p:cNvPicPr>
             <a:picLocks xmlns:a="http://schemas.openxmlformats.org/drawingml/2006/main" noChangeAspect="1"/>
           </p:cNvPicPr>
           <p:nvPr/>
         </p:nvPicPr>
         <p:blipFill>
-          <a:blip xmlns:r="http://schemas.openxmlformats.org/officeDocument/2006/relationships" xmlns:a="http://schemas.openxmlformats.org/drawingml/2006/main" r:embed="R0ae0c801f1aa4049">
+          <a:blip xmlns:r="http://schemas.openxmlformats.org/officeDocument/2006/relationships" xmlns:a="http://schemas.openxmlformats.org/drawingml/2006/main" r:embed="R4611cefa7db44724">
             <a:extLst>
               <a:ext uri="{96DAC541-7B7A-43D3-8B79-37D633B846F1}">
-                <asvg:svgBlip xmlns:asvg="http://schemas.microsoft.com/office/drawing/2016/SVG/main" r:embed="R09b57f759bc44400"/>
+                <asvg:svgBlip xmlns:asvg="http://schemas.microsoft.com/office/drawing/2016/SVG/main" r:embed="R155e09cead574959"/>
               </a:ext>
             </a:extLst>
           </a:blip>
@@ -4210,6 +4301,7 @@
           <a:lstStyle xmlns:a="http://schemas.openxmlformats.org/drawingml/2006/main"/>
           <a:p xmlns:a="http://schemas.openxmlformats.org/drawingml/2006/main">
             <a:pPr algn="l">
+              <a:buNone/>
               <a:defRPr sz="1200" b="0">
                 <a:solidFill>
                   <a:srgbClr val="45D9A0"/>
@@ -4296,6 +4388,7 @@
           <a:lstStyle xmlns:a="http://schemas.openxmlformats.org/drawingml/2006/main"/>
           <a:p xmlns:a="http://schemas.openxmlformats.org/drawingml/2006/main">
             <a:pPr algn="l">
+              <a:buNone/>
               <a:defRPr sz="1050" b="1">
                 <a:solidFill>
                   <a:srgbClr val="78A7FF"/>
@@ -4353,6 +4446,7 @@
           <a:lstStyle xmlns:a="http://schemas.openxmlformats.org/drawingml/2006/main"/>
           <a:p xmlns:a="http://schemas.openxmlformats.org/drawingml/2006/main">
             <a:pPr algn="l">
+              <a:buNone/>
               <a:defRPr sz="3150" b="1">
                 <a:solidFill>
                   <a:srgbClr val="F4F7FB"/>
@@ -4371,7 +4465,7 @@
                 <a:ea typeface="Helvetica Neue"/>
                 <a:cs typeface="Helvetica Neue"/>
               </a:rPr>
-              <a:t>Cảm xúc lẫn lộn chiếm 10/15 lỗi đại diện</a:t>
+              <a:t>15 lỗi minh họa cho thấy ba dạng khó thường gặp</a:t>
             </a:r>
           </a:p>
         </p:txBody>
@@ -4441,6 +4535,7 @@
           <a:lstStyle xmlns:a="http://schemas.openxmlformats.org/drawingml/2006/main"/>
           <a:p xmlns:a="http://schemas.openxmlformats.org/drawingml/2006/main">
             <a:pPr algn="r">
+              <a:buNone/>
               <a:defRPr sz="900" b="0">
                 <a:solidFill>
                   <a:srgbClr val="A7B3C4"/>
@@ -4498,6 +4593,7 @@
           <a:lstStyle xmlns:a="http://schemas.openxmlformats.org/drawingml/2006/main"/>
           <a:p xmlns:a="http://schemas.openxmlformats.org/drawingml/2006/main">
             <a:pPr algn="l">
+              <a:buNone/>
               <a:defRPr sz="975" b="1">
                 <a:solidFill>
                   <a:srgbClr val="FF667B"/>
@@ -4555,6 +4651,7 @@
           <a:lstStyle xmlns:a="http://schemas.openxmlformats.org/drawingml/2006/main"/>
           <a:p xmlns:a="http://schemas.openxmlformats.org/drawingml/2006/main">
             <a:pPr algn="l">
+              <a:buNone/>
               <a:defRPr sz="2850" b="1">
                 <a:solidFill>
                   <a:srgbClr val="F4F7FB"/>
@@ -4573,7 +4670,7 @@
                 <a:ea typeface="Helvetica Neue"/>
                 <a:cs typeface="Helvetica Neue"/>
               </a:rPr>
-              <a:t>442</a:t>
+              <a:t>432</a:t>
             </a:r>
           </a:p>
         </p:txBody>
@@ -4612,6 +4709,7 @@
           <a:lstStyle xmlns:a="http://schemas.openxmlformats.org/drawingml/2006/main"/>
           <a:p xmlns:a="http://schemas.openxmlformats.org/drawingml/2006/main">
             <a:pPr algn="l">
+              <a:buNone/>
               <a:defRPr sz="1575" b="1">
                 <a:solidFill>
                   <a:srgbClr val="F4F7FB"/>
@@ -4630,7 +4728,7 @@
                 <a:ea typeface="Helvetica Neue"/>
                 <a:cs typeface="Helvetica Neue"/>
               </a:rPr>
-              <a:t>26,3% của Final Test</a:t>
+              <a:t>25,7% của Final Test</a:t>
             </a:r>
           </a:p>
         </p:txBody>
@@ -4669,6 +4767,7 @@
           <a:lstStyle xmlns:a="http://schemas.openxmlformats.org/drawingml/2006/main"/>
           <a:p xmlns:a="http://schemas.openxmlformats.org/drawingml/2006/main">
             <a:pPr algn="l">
+              <a:buNone/>
               <a:defRPr sz="1425" b="0">
                 <a:solidFill>
                   <a:srgbClr val="A7B3C4"/>
@@ -4687,7 +4786,7 @@
                 <a:ea typeface="Helvetica Neue"/>
                 <a:cs typeface="Helvetica Neue"/>
               </a:rPr>
-              <a:t>Mẫu thủ công dùng để hiểu dạng lỗi, không đại diện cho toàn bộ 442 lỗi.</a:t>
+              <a:t>15 lỗi được nhóm tự động theo dấu hiệu văn bản; không đại diện toàn bộ 432 lỗi.</a:t>
             </a:r>
           </a:p>
         </p:txBody>
@@ -4726,6 +4825,7 @@
           <a:lstStyle xmlns:a="http://schemas.openxmlformats.org/drawingml/2006/main"/>
           <a:p xmlns:a="http://schemas.openxmlformats.org/drawingml/2006/main">
             <a:pPr algn="l">
+              <a:buNone/>
               <a:defRPr sz="2250" b="1">
                 <a:solidFill>
                   <a:srgbClr val="F4D35E"/>
@@ -4744,7 +4844,7 @@
                 <a:ea typeface="Helvetica Neue"/>
                 <a:cs typeface="Helvetica Neue"/>
               </a:rPr>
-              <a:t>10 / 15</a:t>
+              <a:t>7 / 15</a:t>
             </a:r>
           </a:p>
         </p:txBody>
@@ -4783,6 +4883,7 @@
           <a:lstStyle xmlns:a="http://schemas.openxmlformats.org/drawingml/2006/main"/>
           <a:p xmlns:a="http://schemas.openxmlformats.org/drawingml/2006/main">
             <a:pPr algn="l">
+              <a:buNone/>
               <a:defRPr sz="1875" b="1">
                 <a:solidFill>
                   <a:srgbClr val="F4F7FB"/>
@@ -4801,7 +4902,7 @@
                 <a:ea typeface="Helvetica Neue"/>
                 <a:cs typeface="Helvetica Neue"/>
               </a:rPr>
-              <a:t>Cảm xúc lẫn lộn</a:t>
+              <a:t>Review nhiều vế ý</a:t>
             </a:r>
           </a:p>
         </p:txBody>
@@ -4840,6 +4941,7 @@
           <a:lstStyle xmlns:a="http://schemas.openxmlformats.org/drawingml/2006/main"/>
           <a:p xmlns:a="http://schemas.openxmlformats.org/drawingml/2006/main">
             <a:pPr algn="l">
+              <a:buNone/>
               <a:defRPr sz="1425" b="0">
                 <a:solidFill>
                   <a:srgbClr val="A7B3C4"/>
@@ -4858,7 +4960,7 @@
                 <a:ea typeface="Helvetica Neue"/>
                 <a:cs typeface="Helvetica Neue"/>
               </a:rPr>
-              <a:t>Review vừa khen vừa chê, nên một nhãn duy nhất làm mất sắc thái.</a:t>
+              <a:t>Một review vừa khen vừa chê, nên khó gói vào một nhãn duy nhất.</a:t>
             </a:r>
           </a:p>
         </p:txBody>
@@ -4928,6 +5030,7 @@
           <a:lstStyle xmlns:a="http://schemas.openxmlformats.org/drawingml/2006/main"/>
           <a:p xmlns:a="http://schemas.openxmlformats.org/drawingml/2006/main">
             <a:pPr algn="l">
+              <a:buNone/>
               <a:defRPr sz="2250" b="1">
                 <a:solidFill>
                   <a:srgbClr val="FF9C5A"/>
@@ -4946,7 +5049,7 @@
                 <a:ea typeface="Helvetica Neue"/>
                 <a:cs typeface="Helvetica Neue"/>
               </a:rPr>
-              <a:t>4 / 15</a:t>
+              <a:t>6 / 15</a:t>
             </a:r>
           </a:p>
         </p:txBody>
@@ -4985,6 +5088,7 @@
           <a:lstStyle xmlns:a="http://schemas.openxmlformats.org/drawingml/2006/main"/>
           <a:p xmlns:a="http://schemas.openxmlformats.org/drawingml/2006/main">
             <a:pPr algn="l">
+              <a:buNone/>
               <a:defRPr sz="1875" b="1">
                 <a:solidFill>
                   <a:srgbClr val="F4F7FB"/>
@@ -5003,7 +5107,7 @@
                 <a:ea typeface="Helvetica Neue"/>
                 <a:cs typeface="Helvetica Neue"/>
               </a:rPr>
-              <a:t>Nhãn nhiễu theo rating</a:t>
+              <a:t>Phủ định hoặc cấu trúc khó</a:t>
             </a:r>
           </a:p>
         </p:txBody>
@@ -5042,6 +5146,7 @@
           <a:lstStyle xmlns:a="http://schemas.openxmlformats.org/drawingml/2006/main"/>
           <a:p xmlns:a="http://schemas.openxmlformats.org/drawingml/2006/main">
             <a:pPr algn="l">
+              <a:buNone/>
               <a:defRPr sz="1425" b="0">
                 <a:solidFill>
                   <a:srgbClr val="A7B3C4"/>
@@ -5060,7 +5165,7 @@
                 <a:ea typeface="Helvetica Neue"/>
                 <a:cs typeface="Helvetica Neue"/>
               </a:rPr>
-              <a:t>Giọng văn và nhãn suy ra từ số sao không hoàn toàn nhất quán.</a:t>
+              <a:t>Từ phủ định và câu dài khiến tín hiệu TF-IDF khó diễn giải.</a:t>
             </a:r>
           </a:p>
         </p:txBody>
@@ -5130,6 +5235,7 @@
           <a:lstStyle xmlns:a="http://schemas.openxmlformats.org/drawingml/2006/main"/>
           <a:p xmlns:a="http://schemas.openxmlformats.org/drawingml/2006/main">
             <a:pPr algn="l">
+              <a:buNone/>
               <a:defRPr sz="2250" b="1">
                 <a:solidFill>
                   <a:srgbClr val="78A7FF"/>
@@ -5148,7 +5254,7 @@
                 <a:ea typeface="Helvetica Neue"/>
                 <a:cs typeface="Helvetica Neue"/>
               </a:rPr>
-              <a:t>1 / 15</a:t>
+              <a:t>2 / 15</a:t>
             </a:r>
           </a:p>
         </p:txBody>
@@ -5187,6 +5293,7 @@
           <a:lstStyle xmlns:a="http://schemas.openxmlformats.org/drawingml/2006/main"/>
           <a:p xmlns:a="http://schemas.openxmlformats.org/drawingml/2006/main">
             <a:pPr algn="l">
+              <a:buNone/>
               <a:defRPr sz="1875" b="1">
                 <a:solidFill>
                   <a:srgbClr val="F4F7FB"/>
@@ -5205,7 +5312,7 @@
                 <a:ea typeface="Helvetica Neue"/>
                 <a:cs typeface="Helvetica Neue"/>
               </a:rPr>
-              <a:t>Review dài, đa khía cạnh</a:t>
+              <a:t>Nhãn hoặc tín hiệu chưa rõ</a:t>
             </a:r>
           </a:p>
         </p:txBody>
@@ -5244,6 +5351,7 @@
           <a:lstStyle xmlns:a="http://schemas.openxmlformats.org/drawingml/2006/main"/>
           <a:p xmlns:a="http://schemas.openxmlformats.org/drawingml/2006/main">
             <a:pPr algn="l">
+              <a:buNone/>
               <a:defRPr sz="1425" b="0">
                 <a:solidFill>
                   <a:srgbClr val="A7B3C4"/>
@@ -5262,7 +5370,7 @@
                 <a:ea typeface="Helvetica Neue"/>
                 <a:cs typeface="Helvetica Neue"/>
               </a:rPr>
-              <a:t>Nhiều thời điểm và chủ đề khiến TF-IDF khó tổng hợp thành một cực tính.</a:t>
+              <a:t>Rating và nội dung có thể lệch nhau; một số câu có ít từ model nhận ra.</a:t>
             </a:r>
           </a:p>
         </p:txBody>
@@ -5301,6 +5409,7 @@
           <a:lstStyle xmlns:a="http://schemas.openxmlformats.org/drawingml/2006/main"/>
           <a:p xmlns:a="http://schemas.openxmlformats.org/drawingml/2006/main">
             <a:pPr algn="l">
+              <a:buNone/>
               <a:defRPr sz="1425" b="0">
                 <a:solidFill>
                   <a:srgbClr val="45D9A0"/>
@@ -5319,7 +5428,7 @@
                 <a:ea typeface="Helvetica Neue"/>
                 <a:cs typeface="Helvetica Neue"/>
               </a:rPr>
-              <a:t>Hướng cải thiện phù hợp: gán nhãn thủ công một tập nhỏ và mở rộng sang phân tích cảm xúc theo khía cạnh.</a:t>
+              <a:t>Nhóm lỗi là gợi ý tự động; cần đọc và gán nhãn thủ công thêm trước khi kết luận nguyên nhân.</a:t>
             </a:r>
           </a:p>
         </p:txBody>
@@ -5387,6 +5496,7 @@
           <a:lstStyle xmlns:a="http://schemas.openxmlformats.org/drawingml/2006/main"/>
           <a:p xmlns:a="http://schemas.openxmlformats.org/drawingml/2006/main">
             <a:pPr algn="l">
+              <a:buNone/>
               <a:defRPr sz="1050" b="1">
                 <a:solidFill>
                   <a:srgbClr val="78A7FF"/>
@@ -5444,6 +5554,7 @@
           <a:lstStyle xmlns:a="http://schemas.openxmlformats.org/drawingml/2006/main"/>
           <a:p xmlns:a="http://schemas.openxmlformats.org/drawingml/2006/main">
             <a:pPr algn="l">
+              <a:buNone/>
               <a:defRPr sz="3150" b="1">
                 <a:solidFill>
                   <a:srgbClr val="F4F7FB"/>
@@ -5532,6 +5643,7 @@
           <a:lstStyle xmlns:a="http://schemas.openxmlformats.org/drawingml/2006/main"/>
           <a:p xmlns:a="http://schemas.openxmlformats.org/drawingml/2006/main">
             <a:pPr algn="r">
+              <a:buNone/>
               <a:defRPr sz="900" b="0">
                 <a:solidFill>
                   <a:srgbClr val="A7B3C4"/>
@@ -5557,7 +5669,7 @@
       </p:sp>
       <p:graphicFrame>
         <p:nvGraphicFramePr>
-          <p:cNvPr id="20" name="Chart"/>
+          <p:cNvPr id="22" name="Chart"/>
           <p:cNvGraphicFramePr/>
           <p:nvPr/>
         </p:nvGraphicFramePr>
@@ -5567,7 +5679,7 @@
         </p:xfrm>
         <a:graphic xmlns:a="http://schemas.openxmlformats.org/drawingml/2006/main">
           <a:graphicData uri="http://schemas.openxmlformats.org/drawingml/2006/chart">
-            <c:chart xmlns:r="http://schemas.openxmlformats.org/officeDocument/2006/relationships" xmlns:c="http://schemas.openxmlformats.org/drawingml/2006/chart" r:id="R381f9b6847f64fac"/>
+            <c:chart xmlns:r="http://schemas.openxmlformats.org/officeDocument/2006/relationships" xmlns:c="http://schemas.openxmlformats.org/drawingml/2006/chart" r:id="R0f0d06d4599148b7"/>
           </a:graphicData>
         </a:graphic>
       </p:graphicFrame>
@@ -5638,6 +5750,7 @@
           <a:lstStyle xmlns:a="http://schemas.openxmlformats.org/drawingml/2006/main"/>
           <a:p xmlns:a="http://schemas.openxmlformats.org/drawingml/2006/main">
             <a:pPr algn="l">
+              <a:buNone/>
               <a:defRPr sz="1500" b="1">
                 <a:solidFill>
                   <a:srgbClr val="F4F7FB"/>
@@ -5695,6 +5808,7 @@
           <a:lstStyle xmlns:a="http://schemas.openxmlformats.org/drawingml/2006/main"/>
           <a:p xmlns:a="http://schemas.openxmlformats.org/drawingml/2006/main">
             <a:pPr algn="l">
+              <a:buNone/>
               <a:defRPr sz="1275" b="0">
                 <a:solidFill>
                   <a:srgbClr val="A7B3C4"/>
@@ -5785,6 +5899,7 @@
           <a:lstStyle xmlns:a="http://schemas.openxmlformats.org/drawingml/2006/main"/>
           <a:p xmlns:a="http://schemas.openxmlformats.org/drawingml/2006/main">
             <a:pPr algn="l">
+              <a:buNone/>
               <a:defRPr sz="1500" b="1">
                 <a:solidFill>
                   <a:srgbClr val="F4F7FB"/>
@@ -5842,6 +5957,7 @@
           <a:lstStyle xmlns:a="http://schemas.openxmlformats.org/drawingml/2006/main"/>
           <a:p xmlns:a="http://schemas.openxmlformats.org/drawingml/2006/main">
             <a:pPr algn="l">
+              <a:buNone/>
               <a:defRPr sz="1275" b="0">
                 <a:solidFill>
                   <a:srgbClr val="A7B3C4"/>
@@ -5932,6 +6048,7 @@
           <a:lstStyle xmlns:a="http://schemas.openxmlformats.org/drawingml/2006/main"/>
           <a:p xmlns:a="http://schemas.openxmlformats.org/drawingml/2006/main">
             <a:pPr algn="l">
+              <a:buNone/>
               <a:defRPr sz="1500" b="1">
                 <a:solidFill>
                   <a:srgbClr val="F4F7FB"/>
@@ -5989,6 +6106,7 @@
           <a:lstStyle xmlns:a="http://schemas.openxmlformats.org/drawingml/2006/main"/>
           <a:p xmlns:a="http://schemas.openxmlformats.org/drawingml/2006/main">
             <a:pPr algn="l">
+              <a:buNone/>
               <a:defRPr sz="1275" b="0">
                 <a:solidFill>
                   <a:srgbClr val="A7B3C4"/>
@@ -6046,6 +6164,7 @@
           <a:lstStyle xmlns:a="http://schemas.openxmlformats.org/drawingml/2006/main"/>
           <a:p xmlns:a="http://schemas.openxmlformats.org/drawingml/2006/main">
             <a:pPr algn="l">
+              <a:buNone/>
               <a:defRPr sz="1350" b="0">
                 <a:solidFill>
                   <a:srgbClr val="A7B3C4"/>
@@ -6132,6 +6251,7 @@
           <a:lstStyle xmlns:a="http://schemas.openxmlformats.org/drawingml/2006/main"/>
           <a:p xmlns:a="http://schemas.openxmlformats.org/drawingml/2006/main">
             <a:pPr algn="l">
+              <a:buNone/>
               <a:defRPr sz="1050" b="1">
                 <a:solidFill>
                   <a:srgbClr val="78A7FF"/>
@@ -6189,6 +6309,7 @@
           <a:lstStyle xmlns:a="http://schemas.openxmlformats.org/drawingml/2006/main"/>
           <a:p xmlns:a="http://schemas.openxmlformats.org/drawingml/2006/main">
             <a:pPr algn="l">
+              <a:buNone/>
               <a:defRPr sz="3150" b="1">
                 <a:solidFill>
                   <a:srgbClr val="F4F7FB"/>
@@ -6277,6 +6398,7 @@
           <a:lstStyle xmlns:a="http://schemas.openxmlformats.org/drawingml/2006/main"/>
           <a:p xmlns:a="http://schemas.openxmlformats.org/drawingml/2006/main">
             <a:pPr algn="r">
+              <a:buNone/>
               <a:defRPr sz="900" b="0">
                 <a:solidFill>
                   <a:srgbClr val="A7B3C4"/>
@@ -6302,7 +6424,7 @@
       </p:sp>
       <p:graphicFrame>
         <p:nvGraphicFramePr>
-          <p:cNvPr id="17" name="Chart"/>
+          <p:cNvPr id="19" name="Chart"/>
           <p:cNvGraphicFramePr/>
           <p:nvPr/>
         </p:nvGraphicFramePr>
@@ -6312,7 +6434,7 @@
         </p:xfrm>
         <a:graphic xmlns:a="http://schemas.openxmlformats.org/drawingml/2006/main">
           <a:graphicData uri="http://schemas.openxmlformats.org/drawingml/2006/chart">
-            <c:chart xmlns:r="http://schemas.openxmlformats.org/officeDocument/2006/relationships" xmlns:c="http://schemas.openxmlformats.org/drawingml/2006/chart" r:id="Rbc55fee72ab84298"/>
+            <c:chart xmlns:r="http://schemas.openxmlformats.org/officeDocument/2006/relationships" xmlns:c="http://schemas.openxmlformats.org/drawingml/2006/chart" r:id="Rc85f94e2a97d4378"/>
           </a:graphicData>
         </a:graphic>
       </p:graphicFrame>
@@ -6350,6 +6472,7 @@
           <a:lstStyle xmlns:a="http://schemas.openxmlformats.org/drawingml/2006/main"/>
           <a:p xmlns:a="http://schemas.openxmlformats.org/drawingml/2006/main">
             <a:pPr algn="r">
+              <a:buNone/>
               <a:defRPr sz="900" b="1">
                 <a:solidFill>
                   <a:srgbClr val="A7B3C4"/>
@@ -6368,7 +6491,7 @@
                 <a:ea typeface="Helvetica Neue"/>
                 <a:cs typeface="Helvetica Neue"/>
               </a:rPr>
-              <a:t>TRỌNG SỐ TF-IDF (%)</a:t>
+              <a:t>TRỌNG SỐ TF-IDF (×100)</a:t>
             </a:r>
           </a:p>
         </p:txBody>
@@ -6407,6 +6530,7 @@
           <a:lstStyle xmlns:a="http://schemas.openxmlformats.org/drawingml/2006/main"/>
           <a:p xmlns:a="http://schemas.openxmlformats.org/drawingml/2006/main">
             <a:pPr algn="l">
+              <a:buNone/>
               <a:defRPr sz="975" b="1">
                 <a:solidFill>
                   <a:srgbClr val="FF667B"/>
@@ -6464,6 +6588,7 @@
           <a:lstStyle xmlns:a="http://schemas.openxmlformats.org/drawingml/2006/main"/>
           <a:p xmlns:a="http://schemas.openxmlformats.org/drawingml/2006/main">
             <a:pPr algn="l">
+              <a:buNone/>
               <a:defRPr sz="2850" b="1">
                 <a:solidFill>
                   <a:srgbClr val="F4F7FB"/>
@@ -6482,7 +6607,7 @@
                 <a:ea typeface="Helvetica Neue"/>
                 <a:cs typeface="Helvetica Neue"/>
               </a:rPr>
-              <a:t>84,3%</a:t>
+              <a:t>99,0%</a:t>
             </a:r>
           </a:p>
         </p:txBody>
@@ -6521,6 +6646,7 @@
           <a:lstStyle xmlns:a="http://schemas.openxmlformats.org/drawingml/2006/main"/>
           <a:p xmlns:a="http://schemas.openxmlformats.org/drawingml/2006/main">
             <a:pPr algn="l">
+              <a:buNone/>
               <a:defRPr sz="1575" b="1">
                 <a:solidFill>
                   <a:srgbClr val="78A7FF"/>
@@ -6539,7 +6665,7 @@
                 <a:ea typeface="Helvetica Neue"/>
                 <a:cs typeface="Helvetica Neue"/>
               </a:rPr>
-              <a:t>Bigram có mặt</a:t>
+              <a:t>Cụm từ được giữ lại</a:t>
             </a:r>
           </a:p>
         </p:txBody>
@@ -6578,6 +6704,7 @@
           <a:lstStyle xmlns:a="http://schemas.openxmlformats.org/drawingml/2006/main"/>
           <a:p xmlns:a="http://schemas.openxmlformats.org/drawingml/2006/main">
             <a:pPr algn="l">
+              <a:buNone/>
               <a:defRPr sz="1500" b="0">
                 <a:solidFill>
                   <a:srgbClr val="A7B3C4"/>
@@ -6596,7 +6723,7 @@
                 <a:ea typeface="Helvetica Neue"/>
                 <a:cs typeface="Helvetica Neue"/>
               </a:rPr>
-              <a:t>“không lương” là một đặc trưng riêng trong từ vựng.</a:t>
+              <a:t>“không lương” và “lương thấp” là các đặc trưng riêng.</a:t>
             </a:r>
           </a:p>
         </p:txBody>
@@ -6635,6 +6762,7 @@
           <a:lstStyle xmlns:a="http://schemas.openxmlformats.org/drawingml/2006/main"/>
           <a:p xmlns:a="http://schemas.openxmlformats.org/drawingml/2006/main">
             <a:pPr algn="l">
+              <a:buNone/>
               <a:defRPr sz="1575" b="1">
                 <a:solidFill>
                   <a:srgbClr val="F4D35E"/>
@@ -6692,6 +6820,7 @@
           <a:lstStyle xmlns:a="http://schemas.openxmlformats.org/drawingml/2006/main"/>
           <a:p xmlns:a="http://schemas.openxmlformats.org/drawingml/2006/main">
             <a:pPr algn="l">
+              <a:buNone/>
               <a:defRPr sz="1425" b="0">
                 <a:solidFill>
                   <a:srgbClr val="A7B3C4"/>
@@ -6710,7 +6839,7 @@
                 <a:ea typeface="Helvetica Neue"/>
                 <a:cs typeface="Helvetica Neue"/>
               </a:rPr>
-              <a:t>Trọng số TF-IDF chỉ phản ánh mức nổi bật trong câu. Muốn biết chiều tác động cần kết hợp hệ số của mô hình.</a:t>
+              <a:t>Trọng số TF-IDF cho biết độ nổi bật. Muốn biết chiều tác động cần xem thêm hệ số Logistic Regression.</a:t>
             </a:r>
           </a:p>
         </p:txBody>
@@ -6778,6 +6907,7 @@
           <a:lstStyle xmlns:a="http://schemas.openxmlformats.org/drawingml/2006/main"/>
           <a:p xmlns:a="http://schemas.openxmlformats.org/drawingml/2006/main">
             <a:pPr algn="l">
+              <a:buNone/>
               <a:defRPr sz="1050" b="1">
                 <a:solidFill>
                   <a:srgbClr val="78A7FF"/>
@@ -6830,11 +6960,12 @@
         </p:spPr>
         <p:txBody>
           <a:bodyPr xmlns:a="http://schemas.openxmlformats.org/drawingml/2006/main" anchor="t">
-            <a:normAutofit fontScale="86589"/>
-          </a:bodyPr>
-          <a:lstStyle xmlns:a="http://schemas.openxmlformats.org/drawingml/2006/main"/>
-          <a:p xmlns:a="http://schemas.openxmlformats.org/drawingml/2006/main">
-            <a:pPr algn="l">
+            <a:normAutofit fontScale="100000"/>
+          </a:bodyPr>
+          <a:lstStyle xmlns:a="http://schemas.openxmlformats.org/drawingml/2006/main"/>
+          <a:p xmlns:a="http://schemas.openxmlformats.org/drawingml/2006/main">
+            <a:pPr algn="l">
+              <a:buNone/>
               <a:defRPr sz="3150" b="1">
                 <a:solidFill>
                   <a:srgbClr val="F4F7FB"/>
@@ -6853,7 +6984,7 @@
                 <a:ea typeface="Helvetica Neue"/>
                 <a:cs typeface="Helvetica Neue"/>
               </a:rPr>
-              <a:t>Kết quả ổn định, nhưng trần hiệu năng bị giới hạn bởi nhãn yếu</a:t>
+              <a:t>Bản sửa tốt hơn một chút, nhưng lớp Negative vẫn khó</a:t>
             </a:r>
           </a:p>
         </p:txBody>
@@ -6923,6 +7054,7 @@
           <a:lstStyle xmlns:a="http://schemas.openxmlformats.org/drawingml/2006/main"/>
           <a:p xmlns:a="http://schemas.openxmlformats.org/drawingml/2006/main">
             <a:pPr algn="r">
+              <a:buNone/>
               <a:defRPr sz="900" b="0">
                 <a:solidFill>
                   <a:srgbClr val="A7B3C4"/>
@@ -6980,6 +7112,7 @@
           <a:lstStyle xmlns:a="http://schemas.openxmlformats.org/drawingml/2006/main"/>
           <a:p xmlns:a="http://schemas.openxmlformats.org/drawingml/2006/main">
             <a:pPr algn="l">
+              <a:buNone/>
               <a:defRPr sz="1875" b="1">
                 <a:solidFill>
                   <a:srgbClr val="45D9A0"/>
@@ -7070,6 +7203,7 @@
           <a:lstStyle xmlns:a="http://schemas.openxmlformats.org/drawingml/2006/main"/>
           <a:p xmlns:a="http://schemas.openxmlformats.org/drawingml/2006/main">
             <a:pPr algn="l">
+              <a:buNone/>
               <a:defRPr sz="1575" b="0">
                 <a:solidFill>
                   <a:srgbClr val="F4F7FB"/>
@@ -7160,6 +7294,7 @@
           <a:lstStyle xmlns:a="http://schemas.openxmlformats.org/drawingml/2006/main"/>
           <a:p xmlns:a="http://schemas.openxmlformats.org/drawingml/2006/main">
             <a:pPr algn="l">
+              <a:buNone/>
               <a:defRPr sz="1575" b="0">
                 <a:solidFill>
                   <a:srgbClr val="A7B3C4"/>
@@ -7250,6 +7385,7 @@
           <a:lstStyle xmlns:a="http://schemas.openxmlformats.org/drawingml/2006/main"/>
           <a:p xmlns:a="http://schemas.openxmlformats.org/drawingml/2006/main">
             <a:pPr algn="l">
+              <a:buNone/>
               <a:defRPr sz="1575" b="0">
                 <a:solidFill>
                   <a:srgbClr val="A7B3C4"/>
@@ -7268,7 +7404,7 @@
                 <a:ea typeface="Helvetica Neue"/>
                 <a:cs typeface="Helvetica Neue"/>
               </a:rPr>
-              <a:t>Final Test khóa và web demo</a:t>
+              <a:t>Đối chiếu lại Final Test cũ</a:t>
             </a:r>
           </a:p>
         </p:txBody>
@@ -7338,6 +7474,7 @@
           <a:lstStyle xmlns:a="http://schemas.openxmlformats.org/drawingml/2006/main"/>
           <a:p xmlns:a="http://schemas.openxmlformats.org/drawingml/2006/main">
             <a:pPr algn="l">
+              <a:buNone/>
               <a:defRPr sz="1875" b="1">
                 <a:solidFill>
                   <a:srgbClr val="78A7FF"/>
@@ -7428,6 +7565,7 @@
           <a:lstStyle xmlns:a="http://schemas.openxmlformats.org/drawingml/2006/main"/>
           <a:p xmlns:a="http://schemas.openxmlformats.org/drawingml/2006/main">
             <a:pPr algn="l">
+              <a:buNone/>
               <a:defRPr sz="1575" b="0">
                 <a:solidFill>
                   <a:srgbClr val="F4F7FB"/>
@@ -7518,6 +7656,7 @@
           <a:lstStyle xmlns:a="http://schemas.openxmlformats.org/drawingml/2006/main"/>
           <a:p xmlns:a="http://schemas.openxmlformats.org/drawingml/2006/main">
             <a:pPr algn="l">
+              <a:buNone/>
               <a:defRPr sz="1575" b="0">
                 <a:solidFill>
                   <a:srgbClr val="A7B3C4"/>
@@ -7608,6 +7747,7 @@
           <a:lstStyle xmlns:a="http://schemas.openxmlformats.org/drawingml/2006/main"/>
           <a:p xmlns:a="http://schemas.openxmlformats.org/drawingml/2006/main">
             <a:pPr algn="l">
+              <a:buNone/>
               <a:defRPr sz="1575" b="0">
                 <a:solidFill>
                   <a:srgbClr val="A7B3C4"/>
@@ -7696,6 +7836,7 @@
           <a:lstStyle xmlns:a="http://schemas.openxmlformats.org/drawingml/2006/main"/>
           <a:p xmlns:a="http://schemas.openxmlformats.org/drawingml/2006/main">
             <a:pPr algn="l">
+              <a:buNone/>
               <a:defRPr sz="1875" b="1">
                 <a:solidFill>
                   <a:srgbClr val="FF9C5A"/>
@@ -7786,6 +7927,7 @@
           <a:lstStyle xmlns:a="http://schemas.openxmlformats.org/drawingml/2006/main"/>
           <a:p xmlns:a="http://schemas.openxmlformats.org/drawingml/2006/main">
             <a:pPr algn="l">
+              <a:buNone/>
               <a:defRPr sz="1575" b="0">
                 <a:solidFill>
                   <a:srgbClr val="F4F7FB"/>
@@ -7876,6 +8018,7 @@
           <a:lstStyle xmlns:a="http://schemas.openxmlformats.org/drawingml/2006/main"/>
           <a:p xmlns:a="http://schemas.openxmlformats.org/drawingml/2006/main">
             <a:pPr algn="l">
+              <a:buNone/>
               <a:defRPr sz="1575" b="0">
                 <a:solidFill>
                   <a:srgbClr val="A7B3C4"/>
@@ -7894,7 +8037,7 @@
                 <a:ea typeface="Helvetica Neue"/>
                 <a:cs typeface="Helvetica Neue"/>
               </a:rPr>
-              <a:t>Negative F1 chỉ đạt 0,3806</a:t>
+              <a:t>Negative F1 chỉ đạt 0,3910</a:t>
             </a:r>
           </a:p>
         </p:txBody>
@@ -7966,6 +8109,7 @@
           <a:lstStyle xmlns:a="http://schemas.openxmlformats.org/drawingml/2006/main"/>
           <a:p xmlns:a="http://schemas.openxmlformats.org/drawingml/2006/main">
             <a:pPr algn="l">
+              <a:buNone/>
               <a:defRPr sz="1575" b="0">
                 <a:solidFill>
                   <a:srgbClr val="A7B3C4"/>
@@ -8023,6 +8167,7 @@
           <a:lstStyle xmlns:a="http://schemas.openxmlformats.org/drawingml/2006/main"/>
           <a:p xmlns:a="http://schemas.openxmlformats.org/drawingml/2006/main">
             <a:pPr algn="l">
+              <a:buNone/>
               <a:defRPr sz="1425" b="0">
                 <a:solidFill>
                   <a:srgbClr val="45D9A0"/>
@@ -8041,7 +8186,7 @@
                 <a:ea typeface="Helvetica Neue"/>
                 <a:cs typeface="Helvetica Neue"/>
               </a:rPr>
-              <a:t>CV Macro F1 0,5727 và Final Test 0,5714 chỉ chênh 0,0014, chưa cho thấy overfitting nghiêm trọng.</a:t>
+              <a:t>CV Macro F1 0,5815; Final Test cũ 0,5764. Chênh 0,0052, chưa thấy lệch lớn.</a:t>
             </a:r>
           </a:p>
         </p:txBody>
@@ -8109,6 +8254,7 @@
           <a:lstStyle xmlns:a="http://schemas.openxmlformats.org/drawingml/2006/main"/>
           <a:p xmlns:a="http://schemas.openxmlformats.org/drawingml/2006/main">
             <a:pPr algn="l">
+              <a:buNone/>
               <a:defRPr sz="1050" b="1">
                 <a:solidFill>
                   <a:srgbClr val="78A7FF"/>
@@ -8166,6 +8312,7 @@
           <a:lstStyle xmlns:a="http://schemas.openxmlformats.org/drawingml/2006/main"/>
           <a:p xmlns:a="http://schemas.openxmlformats.org/drawingml/2006/main">
             <a:pPr algn="l">
+              <a:buNone/>
               <a:defRPr sz="3150" b="1">
                 <a:solidFill>
                   <a:srgbClr val="F4F7FB"/>
@@ -8254,6 +8401,7 @@
           <a:lstStyle xmlns:a="http://schemas.openxmlformats.org/drawingml/2006/main"/>
           <a:p xmlns:a="http://schemas.openxmlformats.org/drawingml/2006/main">
             <a:pPr algn="r">
+              <a:buNone/>
               <a:defRPr sz="900" b="0">
                 <a:solidFill>
                   <a:srgbClr val="A7B3C4"/>
@@ -8311,6 +8459,7 @@
           <a:lstStyle xmlns:a="http://schemas.openxmlformats.org/drawingml/2006/main"/>
           <a:p xmlns:a="http://schemas.openxmlformats.org/drawingml/2006/main">
             <a:pPr algn="l">
+              <a:buNone/>
               <a:defRPr sz="1950" b="1">
                 <a:solidFill>
                   <a:srgbClr val="45D9A0"/>
@@ -8401,6 +8550,7 @@
           <a:lstStyle xmlns:a="http://schemas.openxmlformats.org/drawingml/2006/main"/>
           <a:p xmlns:a="http://schemas.openxmlformats.org/drawingml/2006/main">
             <a:pPr algn="l">
+              <a:buNone/>
               <a:defRPr sz="1650" b="1">
                 <a:solidFill>
                   <a:srgbClr val="F4F7FB"/>
@@ -8458,6 +8608,7 @@
           <a:lstStyle xmlns:a="http://schemas.openxmlformats.org/drawingml/2006/main"/>
           <a:p xmlns:a="http://schemas.openxmlformats.org/drawingml/2006/main">
             <a:pPr algn="l">
+              <a:buNone/>
               <a:defRPr sz="1350" b="0">
                 <a:solidFill>
                   <a:srgbClr val="A7B3C4"/>
@@ -8548,6 +8699,7 @@
           <a:lstStyle xmlns:a="http://schemas.openxmlformats.org/drawingml/2006/main"/>
           <a:p xmlns:a="http://schemas.openxmlformats.org/drawingml/2006/main">
             <a:pPr algn="l">
+              <a:buNone/>
               <a:defRPr sz="1650" b="1">
                 <a:solidFill>
                   <a:srgbClr val="F4F7FB"/>
@@ -8605,6 +8757,7 @@
           <a:lstStyle xmlns:a="http://schemas.openxmlformats.org/drawingml/2006/main"/>
           <a:p xmlns:a="http://schemas.openxmlformats.org/drawingml/2006/main">
             <a:pPr algn="l">
+              <a:buNone/>
               <a:defRPr sz="1350" b="0">
                 <a:solidFill>
                   <a:srgbClr val="A7B3C4"/>
@@ -8623,7 +8776,7 @@
                 <a:ea typeface="Helvetica Neue"/>
                 <a:cs typeface="Helvetica Neue"/>
               </a:rPr>
-              <a:t>Chọn model trên Development và mở Final Test một lần.</a:t>
+              <a:t>Chọn bản sửa bằng CV; đối chiếu trên Final Test cũ.</a:t>
             </a:r>
           </a:p>
         </p:txBody>
@@ -8695,6 +8848,7 @@
           <a:lstStyle xmlns:a="http://schemas.openxmlformats.org/drawingml/2006/main"/>
           <a:p xmlns:a="http://schemas.openxmlformats.org/drawingml/2006/main">
             <a:pPr algn="l">
+              <a:buNone/>
               <a:defRPr sz="1650" b="1">
                 <a:solidFill>
                   <a:srgbClr val="F4F7FB"/>
@@ -8752,6 +8906,7 @@
           <a:lstStyle xmlns:a="http://schemas.openxmlformats.org/drawingml/2006/main"/>
           <a:p xmlns:a="http://schemas.openxmlformats.org/drawingml/2006/main">
             <a:pPr algn="l">
+              <a:buNone/>
               <a:defRPr sz="1350" b="0">
                 <a:solidFill>
                   <a:srgbClr val="A7B3C4"/>
@@ -8840,6 +8995,7 @@
           <a:lstStyle xmlns:a="http://schemas.openxmlformats.org/drawingml/2006/main"/>
           <a:p xmlns:a="http://schemas.openxmlformats.org/drawingml/2006/main">
             <a:pPr algn="l">
+              <a:buNone/>
               <a:defRPr sz="1950" b="1">
                 <a:solidFill>
                   <a:srgbClr val="78A7FF"/>
@@ -8930,6 +9086,7 @@
           <a:lstStyle xmlns:a="http://schemas.openxmlformats.org/drawingml/2006/main"/>
           <a:p xmlns:a="http://schemas.openxmlformats.org/drawingml/2006/main">
             <a:pPr algn="l">
+              <a:buNone/>
               <a:defRPr sz="1650" b="1">
                 <a:solidFill>
                   <a:srgbClr val="F4F7FB"/>
@@ -8987,6 +9144,7 @@
           <a:lstStyle xmlns:a="http://schemas.openxmlformats.org/drawingml/2006/main"/>
           <a:p xmlns:a="http://schemas.openxmlformats.org/drawingml/2006/main">
             <a:pPr algn="l">
+              <a:buNone/>
               <a:defRPr sz="1350" b="0">
                 <a:solidFill>
                   <a:srgbClr val="A7B3C4"/>
@@ -9077,6 +9235,7 @@
           <a:lstStyle xmlns:a="http://schemas.openxmlformats.org/drawingml/2006/main"/>
           <a:p xmlns:a="http://schemas.openxmlformats.org/drawingml/2006/main">
             <a:pPr algn="l">
+              <a:buNone/>
               <a:defRPr sz="1650" b="1">
                 <a:solidFill>
                   <a:srgbClr val="F4F7FB"/>
@@ -9134,6 +9293,7 @@
           <a:lstStyle xmlns:a="http://schemas.openxmlformats.org/drawingml/2006/main"/>
           <a:p xmlns:a="http://schemas.openxmlformats.org/drawingml/2006/main">
             <a:pPr algn="l">
+              <a:buNone/>
               <a:defRPr sz="1350" b="0">
                 <a:solidFill>
                   <a:srgbClr val="A7B3C4"/>
@@ -9224,6 +9384,7 @@
           <a:lstStyle xmlns:a="http://schemas.openxmlformats.org/drawingml/2006/main"/>
           <a:p xmlns:a="http://schemas.openxmlformats.org/drawingml/2006/main">
             <a:pPr algn="l">
+              <a:buNone/>
               <a:defRPr sz="1650" b="1">
                 <a:solidFill>
                   <a:srgbClr val="F4F7FB"/>
@@ -9281,6 +9442,7 @@
           <a:lstStyle xmlns:a="http://schemas.openxmlformats.org/drawingml/2006/main"/>
           <a:p xmlns:a="http://schemas.openxmlformats.org/drawingml/2006/main">
             <a:pPr algn="l">
+              <a:buNone/>
               <a:defRPr sz="1350" b="0">
                 <a:solidFill>
                   <a:srgbClr val="A7B3C4"/>
@@ -9338,6 +9500,7 @@
           <a:lstStyle xmlns:a="http://schemas.openxmlformats.org/drawingml/2006/main"/>
           <a:p xmlns:a="http://schemas.openxmlformats.org/drawingml/2006/main">
             <a:pPr algn="l">
+              <a:buNone/>
               <a:defRPr sz="2100" b="1">
                 <a:solidFill>
                   <a:srgbClr val="45D9A0"/>
@@ -9424,6 +9587,7 @@
           <a:lstStyle xmlns:a="http://schemas.openxmlformats.org/drawingml/2006/main"/>
           <a:p xmlns:a="http://schemas.openxmlformats.org/drawingml/2006/main">
             <a:pPr algn="l">
+              <a:buNone/>
               <a:defRPr sz="1050" b="1">
                 <a:solidFill>
                   <a:srgbClr val="78A7FF"/>
@@ -9481,6 +9645,7 @@
           <a:lstStyle xmlns:a="http://schemas.openxmlformats.org/drawingml/2006/main"/>
           <a:p xmlns:a="http://schemas.openxmlformats.org/drawingml/2006/main">
             <a:pPr algn="l">
+              <a:buNone/>
               <a:defRPr sz="3150" b="1">
                 <a:solidFill>
                   <a:srgbClr val="F4F7FB"/>
@@ -9569,6 +9734,7 @@
           <a:lstStyle xmlns:a="http://schemas.openxmlformats.org/drawingml/2006/main"/>
           <a:p xmlns:a="http://schemas.openxmlformats.org/drawingml/2006/main">
             <a:pPr algn="r">
+              <a:buNone/>
               <a:defRPr sz="900" b="0">
                 <a:solidFill>
                   <a:srgbClr val="A7B3C4"/>
@@ -9626,6 +9792,7 @@
           <a:lstStyle xmlns:a="http://schemas.openxmlformats.org/drawingml/2006/main"/>
           <a:p xmlns:a="http://schemas.openxmlformats.org/drawingml/2006/main">
             <a:pPr algn="l">
+              <a:buNone/>
               <a:defRPr sz="1050" b="1">
                 <a:solidFill>
                   <a:srgbClr val="78A7FF"/>
@@ -9683,6 +9850,7 @@
           <a:lstStyle xmlns:a="http://schemas.openxmlformats.org/drawingml/2006/main"/>
           <a:p xmlns:a="http://schemas.openxmlformats.org/drawingml/2006/main">
             <a:pPr algn="l">
+              <a:buNone/>
               <a:defRPr sz="2850" b="1">
                 <a:solidFill>
                   <a:srgbClr val="45D9A0"/>
@@ -9740,6 +9908,7 @@
           <a:lstStyle xmlns:a="http://schemas.openxmlformats.org/drawingml/2006/main"/>
           <a:p xmlns:a="http://schemas.openxmlformats.org/drawingml/2006/main">
             <a:pPr algn="l">
+              <a:buNone/>
               <a:defRPr sz="1725" b="0">
                 <a:solidFill>
                   <a:srgbClr val="A7B3C4"/>
@@ -9828,6 +9997,7 @@
           <a:lstStyle xmlns:a="http://schemas.openxmlformats.org/drawingml/2006/main"/>
           <a:p xmlns:a="http://schemas.openxmlformats.org/drawingml/2006/main">
             <a:pPr algn="l">
+              <a:buNone/>
               <a:defRPr sz="1800" b="1">
                 <a:solidFill>
                   <a:srgbClr val="78A7FF"/>
@@ -9885,6 +10055,7 @@
           <a:lstStyle xmlns:a="http://schemas.openxmlformats.org/drawingml/2006/main"/>
           <a:p xmlns:a="http://schemas.openxmlformats.org/drawingml/2006/main">
             <a:pPr algn="l">
+              <a:buNone/>
               <a:defRPr sz="1800" b="1">
                 <a:solidFill>
                   <a:srgbClr val="F4F7FB"/>
@@ -9903,7 +10074,7 @@
                 <a:ea typeface="Helvetica Neue"/>
                 <a:cs typeface="Helvetica Neue"/>
               </a:rPr>
-              <a:t>Nhập review mới</a:t>
+              <a:t>Chọn review mẫu</a:t>
             </a:r>
           </a:p>
         </p:txBody>
@@ -9937,11 +10108,12 @@
         </p:spPr>
         <p:txBody>
           <a:bodyPr xmlns:a="http://schemas.openxmlformats.org/drawingml/2006/main" anchor="t">
-            <a:normAutofit fontScale="98148"/>
-          </a:bodyPr>
-          <a:lstStyle xmlns:a="http://schemas.openxmlformats.org/drawingml/2006/main"/>
-          <a:p xmlns:a="http://schemas.openxmlformats.org/drawingml/2006/main">
-            <a:pPr algn="l">
+            <a:normAutofit fontScale="100000"/>
+          </a:bodyPr>
+          <a:lstStyle xmlns:a="http://schemas.openxmlformats.org/drawingml/2006/main"/>
+          <a:p xmlns:a="http://schemas.openxmlformats.org/drawingml/2006/main">
+            <a:pPr algn="l">
+              <a:buNone/>
               <a:defRPr sz="1350" b="0">
                 <a:solidFill>
                   <a:srgbClr val="A7B3C4"/>
@@ -9960,7 +10132,7 @@
                 <a:ea typeface="Helvetica Neue"/>
                 <a:cs typeface="Helvetica Neue"/>
               </a:rPr>
-              <a:t>Sử dụng một câu tiếng Việt chưa có trong dữ liệu huấn luyện</a:t>
+              <a:t>Bấm mẫu “Nhiều vế” có sẵn trong ứng dụng</a:t>
             </a:r>
           </a:p>
         </p:txBody>
@@ -9999,6 +10171,7 @@
           <a:lstStyle xmlns:a="http://schemas.openxmlformats.org/drawingml/2006/main"/>
           <a:p xmlns:a="http://schemas.openxmlformats.org/drawingml/2006/main">
             <a:pPr algn="l">
+              <a:buNone/>
               <a:defRPr sz="1800" b="1">
                 <a:solidFill>
                   <a:srgbClr val="45D9A0"/>
@@ -10056,6 +10229,7 @@
           <a:lstStyle xmlns:a="http://schemas.openxmlformats.org/drawingml/2006/main"/>
           <a:p xmlns:a="http://schemas.openxmlformats.org/drawingml/2006/main">
             <a:pPr algn="l">
+              <a:buNone/>
               <a:defRPr sz="1800" b="1">
                 <a:solidFill>
                   <a:srgbClr val="F4F7FB"/>
@@ -10113,6 +10287,7 @@
           <a:lstStyle xmlns:a="http://schemas.openxmlformats.org/drawingml/2006/main"/>
           <a:p xmlns:a="http://schemas.openxmlformats.org/drawingml/2006/main">
             <a:pPr algn="l">
+              <a:buNone/>
               <a:defRPr sz="1350" b="0">
                 <a:solidFill>
                   <a:srgbClr val="A7B3C4"/>
@@ -10170,6 +10345,7 @@
           <a:lstStyle xmlns:a="http://schemas.openxmlformats.org/drawingml/2006/main"/>
           <a:p xmlns:a="http://schemas.openxmlformats.org/drawingml/2006/main">
             <a:pPr algn="l">
+              <a:buNone/>
               <a:defRPr sz="1800" b="1">
                 <a:solidFill>
                   <a:srgbClr val="F4D35E"/>
@@ -10227,6 +10403,7 @@
           <a:lstStyle xmlns:a="http://schemas.openxmlformats.org/drawingml/2006/main"/>
           <a:p xmlns:a="http://schemas.openxmlformats.org/drawingml/2006/main">
             <a:pPr algn="l">
+              <a:buNone/>
               <a:defRPr sz="1800" b="1">
                 <a:solidFill>
                   <a:srgbClr val="F4F7FB"/>
@@ -10284,6 +10461,7 @@
           <a:lstStyle xmlns:a="http://schemas.openxmlformats.org/drawingml/2006/main"/>
           <a:p xmlns:a="http://schemas.openxmlformats.org/drawingml/2006/main">
             <a:pPr algn="l">
+              <a:buNone/>
               <a:defRPr sz="1350" b="0">
                 <a:solidFill>
                   <a:srgbClr val="A7B3C4"/>
@@ -10341,6 +10519,7 @@
           <a:lstStyle xmlns:a="http://schemas.openxmlformats.org/drawingml/2006/main"/>
           <a:p xmlns:a="http://schemas.openxmlformats.org/drawingml/2006/main">
             <a:pPr algn="l">
+              <a:buNone/>
               <a:defRPr sz="1500" b="0">
                 <a:solidFill>
                   <a:srgbClr val="45D9A0"/>
@@ -10427,6 +10606,7 @@
           <a:lstStyle xmlns:a="http://schemas.openxmlformats.org/drawingml/2006/main"/>
           <a:p xmlns:a="http://schemas.openxmlformats.org/drawingml/2006/main">
             <a:pPr algn="l">
+              <a:buNone/>
               <a:defRPr sz="1050" b="1">
                 <a:solidFill>
                   <a:srgbClr val="78A7FF"/>
@@ -10484,6 +10664,7 @@
           <a:lstStyle xmlns:a="http://schemas.openxmlformats.org/drawingml/2006/main"/>
           <a:p xmlns:a="http://schemas.openxmlformats.org/drawingml/2006/main">
             <a:pPr algn="l">
+              <a:buNone/>
               <a:defRPr sz="3150" b="1">
                 <a:solidFill>
                   <a:srgbClr val="F4F7FB"/>
@@ -10572,6 +10753,7 @@
           <a:lstStyle xmlns:a="http://schemas.openxmlformats.org/drawingml/2006/main"/>
           <a:p xmlns:a="http://schemas.openxmlformats.org/drawingml/2006/main">
             <a:pPr algn="r">
+              <a:buNone/>
               <a:defRPr sz="900" b="0">
                 <a:solidFill>
                   <a:srgbClr val="A7B3C4"/>
@@ -10629,6 +10811,7 @@
           <a:lstStyle xmlns:a="http://schemas.openxmlformats.org/drawingml/2006/main"/>
           <a:p xmlns:a="http://schemas.openxmlformats.org/drawingml/2006/main">
             <a:pPr algn="l">
+              <a:buNone/>
               <a:defRPr sz="975" b="1">
                 <a:solidFill>
                   <a:srgbClr val="FF9C5A"/>
@@ -10686,6 +10869,7 @@
           <a:lstStyle xmlns:a="http://schemas.openxmlformats.org/drawingml/2006/main"/>
           <a:p xmlns:a="http://schemas.openxmlformats.org/drawingml/2006/main">
             <a:pPr algn="l">
+              <a:buNone/>
               <a:defRPr sz="2850" b="1">
                 <a:solidFill>
                   <a:srgbClr val="F4F7FB"/>
@@ -10743,6 +10927,7 @@
           <a:lstStyle xmlns:a="http://schemas.openxmlformats.org/drawingml/2006/main"/>
           <a:p xmlns:a="http://schemas.openxmlformats.org/drawingml/2006/main">
             <a:pPr algn="l">
+              <a:buNone/>
               <a:defRPr sz="1575" b="0">
                 <a:solidFill>
                   <a:srgbClr val="A7B3C4"/>
@@ -10768,7 +10953,7 @@
       </p:sp>
       <p:graphicFrame>
         <p:nvGraphicFramePr>
-          <p:cNvPr id="26" name="Chart"/>
+          <p:cNvPr id="28" name="Chart"/>
           <p:cNvGraphicFramePr/>
           <p:nvPr/>
         </p:nvGraphicFramePr>
@@ -10778,7 +10963,7 @@
         </p:xfrm>
         <a:graphic xmlns:a="http://schemas.openxmlformats.org/drawingml/2006/main">
           <a:graphicData uri="http://schemas.openxmlformats.org/drawingml/2006/chart">
-            <c:chart xmlns:r="http://schemas.openxmlformats.org/officeDocument/2006/relationships" xmlns:c="http://schemas.openxmlformats.org/drawingml/2006/chart" r:id="R8918c08e884f4be7"/>
+            <c:chart xmlns:r="http://schemas.openxmlformats.org/officeDocument/2006/relationships" xmlns:c="http://schemas.openxmlformats.org/drawingml/2006/chart" r:id="Rd715ca4579904bc8"/>
           </a:graphicData>
         </a:graphic>
       </p:graphicFrame>
@@ -10816,6 +11001,7 @@
           <a:lstStyle xmlns:a="http://schemas.openxmlformats.org/drawingml/2006/main"/>
           <a:p xmlns:a="http://schemas.openxmlformats.org/drawingml/2006/main">
             <a:pPr algn="l">
+              <a:buNone/>
               <a:defRPr sz="900" b="1">
                 <a:solidFill>
                   <a:srgbClr val="A7B3C4"/>
@@ -10906,6 +11092,7 @@
           <a:lstStyle xmlns:a="http://schemas.openxmlformats.org/drawingml/2006/main"/>
           <a:p xmlns:a="http://schemas.openxmlformats.org/drawingml/2006/main">
             <a:pPr algn="l">
+              <a:buNone/>
               <a:defRPr sz="1575" b="1">
                 <a:solidFill>
                   <a:srgbClr val="F4F7FB"/>
@@ -10963,6 +11150,7 @@
           <a:lstStyle xmlns:a="http://schemas.openxmlformats.org/drawingml/2006/main"/>
           <a:p xmlns:a="http://schemas.openxmlformats.org/drawingml/2006/main">
             <a:pPr algn="l">
+              <a:buNone/>
               <a:defRPr sz="1350" b="0">
                 <a:solidFill>
                   <a:srgbClr val="A7B3C4"/>
@@ -11053,6 +11241,7 @@
           <a:lstStyle xmlns:a="http://schemas.openxmlformats.org/drawingml/2006/main"/>
           <a:p xmlns:a="http://schemas.openxmlformats.org/drawingml/2006/main">
             <a:pPr algn="l">
+              <a:buNone/>
               <a:defRPr sz="1575" b="1">
                 <a:solidFill>
                   <a:srgbClr val="F4F7FB"/>
@@ -11110,6 +11299,7 @@
           <a:lstStyle xmlns:a="http://schemas.openxmlformats.org/drawingml/2006/main"/>
           <a:p xmlns:a="http://schemas.openxmlformats.org/drawingml/2006/main">
             <a:pPr algn="l">
+              <a:buNone/>
               <a:defRPr sz="1350" b="0">
                 <a:solidFill>
                   <a:srgbClr val="A7B3C4"/>
@@ -11200,6 +11390,7 @@
           <a:lstStyle xmlns:a="http://schemas.openxmlformats.org/drawingml/2006/main"/>
           <a:p xmlns:a="http://schemas.openxmlformats.org/drawingml/2006/main">
             <a:pPr algn="l">
+              <a:buNone/>
               <a:defRPr sz="1575" b="1">
                 <a:solidFill>
                   <a:srgbClr val="F4F7FB"/>
@@ -11257,6 +11448,7 @@
           <a:lstStyle xmlns:a="http://schemas.openxmlformats.org/drawingml/2006/main"/>
           <a:p xmlns:a="http://schemas.openxmlformats.org/drawingml/2006/main">
             <a:pPr algn="l">
+              <a:buNone/>
               <a:defRPr sz="1350" b="0">
                 <a:solidFill>
                   <a:srgbClr val="A7B3C4"/>
@@ -11343,6 +11535,7 @@
           <a:lstStyle xmlns:a="http://schemas.openxmlformats.org/drawingml/2006/main"/>
           <a:p xmlns:a="http://schemas.openxmlformats.org/drawingml/2006/main">
             <a:pPr algn="l">
+              <a:buNone/>
               <a:defRPr sz="1050" b="1">
                 <a:solidFill>
                   <a:srgbClr val="78A7FF"/>
@@ -11400,6 +11593,7 @@
           <a:lstStyle xmlns:a="http://schemas.openxmlformats.org/drawingml/2006/main"/>
           <a:p xmlns:a="http://schemas.openxmlformats.org/drawingml/2006/main">
             <a:pPr algn="l">
+              <a:buNone/>
               <a:defRPr sz="3150" b="1">
                 <a:solidFill>
                   <a:srgbClr val="F4F7FB"/>
@@ -11488,6 +11682,7 @@
           <a:lstStyle xmlns:a="http://schemas.openxmlformats.org/drawingml/2006/main"/>
           <a:p xmlns:a="http://schemas.openxmlformats.org/drawingml/2006/main">
             <a:pPr algn="r">
+              <a:buNone/>
               <a:defRPr sz="900" b="0">
                 <a:solidFill>
                   <a:srgbClr val="A7B3C4"/>
@@ -11545,6 +11740,7 @@
           <a:lstStyle xmlns:a="http://schemas.openxmlformats.org/drawingml/2006/main"/>
           <a:p xmlns:a="http://schemas.openxmlformats.org/drawingml/2006/main">
             <a:pPr algn="l">
+              <a:buNone/>
               <a:defRPr sz="1350" b="1">
                 <a:solidFill>
                   <a:srgbClr val="78A7FF"/>
@@ -11602,6 +11798,7 @@
           <a:lstStyle xmlns:a="http://schemas.openxmlformats.org/drawingml/2006/main"/>
           <a:p xmlns:a="http://schemas.openxmlformats.org/drawingml/2006/main">
             <a:pPr algn="l">
+              <a:buNone/>
               <a:defRPr sz="1875" b="1">
                 <a:solidFill>
                   <a:srgbClr val="F4F7FB"/>
@@ -11659,6 +11856,7 @@
           <a:lstStyle xmlns:a="http://schemas.openxmlformats.org/drawingml/2006/main"/>
           <a:p xmlns:a="http://schemas.openxmlformats.org/drawingml/2006/main">
             <a:pPr algn="l">
+              <a:buNone/>
               <a:defRPr sz="1275" b="0">
                 <a:solidFill>
                   <a:srgbClr val="A7B3C4"/>
@@ -11682,6 +11880,7 @@
           </a:p>
           <a:p xmlns:a="http://schemas.openxmlformats.org/drawingml/2006/main">
             <a:pPr algn="l">
+              <a:buNone/>
               <a:defRPr sz="1275" b="0">
                 <a:solidFill>
                   <a:srgbClr val="A7B3C4"/>
@@ -11772,6 +11971,7 @@
           <a:lstStyle xmlns:a="http://schemas.openxmlformats.org/drawingml/2006/main"/>
           <a:p xmlns:a="http://schemas.openxmlformats.org/drawingml/2006/main">
             <a:pPr algn="l">
+              <a:buNone/>
               <a:defRPr sz="1350" b="1">
                 <a:solidFill>
                   <a:srgbClr val="45D9A0"/>
@@ -11829,6 +12029,7 @@
           <a:lstStyle xmlns:a="http://schemas.openxmlformats.org/drawingml/2006/main"/>
           <a:p xmlns:a="http://schemas.openxmlformats.org/drawingml/2006/main">
             <a:pPr algn="l">
+              <a:buNone/>
               <a:defRPr sz="1875" b="1">
                 <a:solidFill>
                   <a:srgbClr val="F4F7FB"/>
@@ -11886,6 +12087,7 @@
           <a:lstStyle xmlns:a="http://schemas.openxmlformats.org/drawingml/2006/main"/>
           <a:p xmlns:a="http://schemas.openxmlformats.org/drawingml/2006/main">
             <a:pPr algn="l">
+              <a:buNone/>
               <a:defRPr sz="1275" b="0">
                 <a:solidFill>
                   <a:srgbClr val="A7B3C4"/>
@@ -11909,6 +12111,7 @@
           </a:p>
           <a:p xmlns:a="http://schemas.openxmlformats.org/drawingml/2006/main">
             <a:pPr algn="l">
+              <a:buNone/>
               <a:defRPr sz="1275" b="0">
                 <a:solidFill>
                   <a:srgbClr val="A7B3C4"/>
@@ -11999,6 +12202,7 @@
           <a:lstStyle xmlns:a="http://schemas.openxmlformats.org/drawingml/2006/main"/>
           <a:p xmlns:a="http://schemas.openxmlformats.org/drawingml/2006/main">
             <a:pPr algn="l">
+              <a:buNone/>
               <a:defRPr sz="1350" b="1">
                 <a:solidFill>
                   <a:srgbClr val="F4D35E"/>
@@ -12056,6 +12260,7 @@
           <a:lstStyle xmlns:a="http://schemas.openxmlformats.org/drawingml/2006/main"/>
           <a:p xmlns:a="http://schemas.openxmlformats.org/drawingml/2006/main">
             <a:pPr algn="l">
+              <a:buNone/>
               <a:defRPr sz="1875" b="1">
                 <a:solidFill>
                   <a:srgbClr val="F4F7FB"/>
@@ -12113,6 +12318,7 @@
           <a:lstStyle xmlns:a="http://schemas.openxmlformats.org/drawingml/2006/main"/>
           <a:p xmlns:a="http://schemas.openxmlformats.org/drawingml/2006/main">
             <a:pPr algn="l">
+              <a:buNone/>
               <a:defRPr sz="1275" b="0">
                 <a:solidFill>
                   <a:srgbClr val="A7B3C4"/>
@@ -12136,6 +12342,7 @@
           </a:p>
           <a:p xmlns:a="http://schemas.openxmlformats.org/drawingml/2006/main">
             <a:pPr algn="l">
+              <a:buNone/>
               <a:defRPr sz="1275" b="0">
                 <a:solidFill>
                   <a:srgbClr val="A7B3C4"/>
@@ -12226,6 +12433,7 @@
           <a:lstStyle xmlns:a="http://schemas.openxmlformats.org/drawingml/2006/main"/>
           <a:p xmlns:a="http://schemas.openxmlformats.org/drawingml/2006/main">
             <a:pPr algn="l">
+              <a:buNone/>
               <a:defRPr sz="1350" b="1">
                 <a:solidFill>
                   <a:srgbClr val="FF9C5A"/>
@@ -12283,6 +12491,7 @@
           <a:lstStyle xmlns:a="http://schemas.openxmlformats.org/drawingml/2006/main"/>
           <a:p xmlns:a="http://schemas.openxmlformats.org/drawingml/2006/main">
             <a:pPr algn="l">
+              <a:buNone/>
               <a:defRPr sz="1875" b="1">
                 <a:solidFill>
                   <a:srgbClr val="F4F7FB"/>
@@ -12340,6 +12549,7 @@
           <a:lstStyle xmlns:a="http://schemas.openxmlformats.org/drawingml/2006/main"/>
           <a:p xmlns:a="http://schemas.openxmlformats.org/drawingml/2006/main">
             <a:pPr algn="l">
+              <a:buNone/>
               <a:defRPr sz="1275" b="0">
                 <a:solidFill>
                   <a:srgbClr val="A7B3C4"/>
@@ -12363,6 +12573,7 @@
           </a:p>
           <a:p xmlns:a="http://schemas.openxmlformats.org/drawingml/2006/main">
             <a:pPr algn="l">
+              <a:buNone/>
               <a:defRPr sz="1275" b="0">
                 <a:solidFill>
                   <a:srgbClr val="A7B3C4"/>
@@ -12453,6 +12664,7 @@
           <a:lstStyle xmlns:a="http://schemas.openxmlformats.org/drawingml/2006/main"/>
           <a:p xmlns:a="http://schemas.openxmlformats.org/drawingml/2006/main">
             <a:pPr algn="l">
+              <a:buNone/>
               <a:defRPr sz="1350" b="1">
                 <a:solidFill>
                   <a:srgbClr val="FF667B"/>
@@ -12510,6 +12722,7 @@
           <a:lstStyle xmlns:a="http://schemas.openxmlformats.org/drawingml/2006/main"/>
           <a:p xmlns:a="http://schemas.openxmlformats.org/drawingml/2006/main">
             <a:pPr algn="l">
+              <a:buNone/>
               <a:defRPr sz="1875" b="1">
                 <a:solidFill>
                   <a:srgbClr val="F4F7FB"/>
@@ -12567,6 +12780,7 @@
           <a:lstStyle xmlns:a="http://schemas.openxmlformats.org/drawingml/2006/main"/>
           <a:p xmlns:a="http://schemas.openxmlformats.org/drawingml/2006/main">
             <a:pPr algn="l">
+              <a:buNone/>
               <a:defRPr sz="1275" b="0">
                 <a:solidFill>
                   <a:srgbClr val="A7B3C4"/>
@@ -12590,6 +12804,7 @@
           </a:p>
           <a:p xmlns:a="http://schemas.openxmlformats.org/drawingml/2006/main">
             <a:pPr algn="l">
+              <a:buNone/>
               <a:defRPr sz="1275" b="0">
                 <a:solidFill>
                   <a:srgbClr val="A7B3C4"/>
@@ -12648,7 +12863,7 @@
       </p:sp>
       <p:cxnSp>
         <p:nvCxnSpPr>
-          <p:cNvPr id="58" name=""/>
+          <p:cNvPr id="114" name=""/>
           <p:cNvCxnSpPr>
             <a:stCxn xmlns:a="http://schemas.openxmlformats.org/drawingml/2006/main" id="8" idx="3"/>
             <a:endCxn xmlns:a="http://schemas.openxmlformats.org/drawingml/2006/main" id="12" idx="1"/>
@@ -12674,7 +12889,7 @@
       </p:cxnSp>
       <p:cxnSp>
         <p:nvCxnSpPr>
-          <p:cNvPr id="59" name=""/>
+          <p:cNvPr id="115" name=""/>
           <p:cNvCxnSpPr>
             <a:stCxn xmlns:a="http://schemas.openxmlformats.org/drawingml/2006/main" id="12" idx="3"/>
             <a:endCxn xmlns:a="http://schemas.openxmlformats.org/drawingml/2006/main" id="16" idx="1"/>
@@ -12700,7 +12915,7 @@
       </p:cxnSp>
       <p:cxnSp>
         <p:nvCxnSpPr>
-          <p:cNvPr id="60" name=""/>
+          <p:cNvPr id="116" name=""/>
           <p:cNvCxnSpPr>
             <a:stCxn xmlns:a="http://schemas.openxmlformats.org/drawingml/2006/main" id="16" idx="3"/>
             <a:endCxn xmlns:a="http://schemas.openxmlformats.org/drawingml/2006/main" id="20" idx="1"/>
@@ -12726,7 +12941,7 @@
       </p:cxnSp>
       <p:cxnSp>
         <p:nvCxnSpPr>
-          <p:cNvPr id="61" name=""/>
+          <p:cNvPr id="117" name=""/>
           <p:cNvCxnSpPr>
             <a:stCxn xmlns:a="http://schemas.openxmlformats.org/drawingml/2006/main" id="20" idx="3"/>
             <a:endCxn xmlns:a="http://schemas.openxmlformats.org/drawingml/2006/main" id="24" idx="1"/>
@@ -12819,6 +13034,7 @@
           <a:lstStyle xmlns:a="http://schemas.openxmlformats.org/drawingml/2006/main"/>
           <a:p xmlns:a="http://schemas.openxmlformats.org/drawingml/2006/main">
             <a:pPr algn="l">
+              <a:buNone/>
               <a:defRPr sz="1200" b="1">
                 <a:solidFill>
                   <a:srgbClr val="78A7FF"/>
@@ -12876,6 +13092,7 @@
           <a:lstStyle xmlns:a="http://schemas.openxmlformats.org/drawingml/2006/main"/>
           <a:p xmlns:a="http://schemas.openxmlformats.org/drawingml/2006/main">
             <a:pPr algn="l">
+              <a:buNone/>
               <a:defRPr sz="1950" b="1">
                 <a:solidFill>
                   <a:srgbClr val="45D9A0"/>
@@ -12933,6 +13150,7 @@
           <a:lstStyle xmlns:a="http://schemas.openxmlformats.org/drawingml/2006/main"/>
           <a:p xmlns:a="http://schemas.openxmlformats.org/drawingml/2006/main">
             <a:pPr algn="l">
+              <a:buNone/>
               <a:defRPr sz="1875" b="1">
                 <a:solidFill>
                   <a:srgbClr val="F4F7FB"/>
@@ -12951,7 +13169,7 @@
                 <a:ea typeface="Helvetica Neue"/>
                 <a:cs typeface="Helvetica Neue"/>
               </a:rPr>
-              <a:t>Final Test: Macro F1 0,5714</a:t>
+              <a:t>Final Test: Macro F1 0,5764</a:t>
             </a:r>
           </a:p>
         </p:txBody>
@@ -12990,6 +13208,7 @@
           <a:lstStyle xmlns:a="http://schemas.openxmlformats.org/drawingml/2006/main"/>
           <a:p xmlns:a="http://schemas.openxmlformats.org/drawingml/2006/main">
             <a:pPr algn="l">
+              <a:buNone/>
               <a:defRPr sz="1575" b="0">
                 <a:solidFill>
                   <a:srgbClr val="A7B3C4"/>
@@ -13076,6 +13295,7 @@
           <a:lstStyle xmlns:a="http://schemas.openxmlformats.org/drawingml/2006/main"/>
           <a:p xmlns:a="http://schemas.openxmlformats.org/drawingml/2006/main">
             <a:pPr algn="l">
+              <a:buNone/>
               <a:defRPr sz="1050" b="1">
                 <a:solidFill>
                   <a:srgbClr val="78A7FF"/>
@@ -13133,6 +13353,7 @@
           <a:lstStyle xmlns:a="http://schemas.openxmlformats.org/drawingml/2006/main"/>
           <a:p xmlns:a="http://schemas.openxmlformats.org/drawingml/2006/main">
             <a:pPr algn="l">
+              <a:buNone/>
               <a:defRPr sz="3150" b="1">
                 <a:solidFill>
                   <a:srgbClr val="F4F7FB"/>
@@ -13221,6 +13442,7 @@
           <a:lstStyle xmlns:a="http://schemas.openxmlformats.org/drawingml/2006/main"/>
           <a:p xmlns:a="http://schemas.openxmlformats.org/drawingml/2006/main">
             <a:pPr algn="r">
+              <a:buNone/>
               <a:defRPr sz="900" b="0">
                 <a:solidFill>
                   <a:srgbClr val="A7B3C4"/>
@@ -13311,6 +13533,7 @@
           <a:lstStyle xmlns:a="http://schemas.openxmlformats.org/drawingml/2006/main"/>
           <a:p xmlns:a="http://schemas.openxmlformats.org/drawingml/2006/main">
             <a:pPr algn="l">
+              <a:buNone/>
               <a:defRPr sz="1725" b="1">
                 <a:solidFill>
                   <a:srgbClr val="F4F7FB"/>
@@ -13368,6 +13591,7 @@
           <a:lstStyle xmlns:a="http://schemas.openxmlformats.org/drawingml/2006/main"/>
           <a:p xmlns:a="http://schemas.openxmlformats.org/drawingml/2006/main">
             <a:pPr algn="l">
+              <a:buNone/>
               <a:defRPr sz="1350" b="0">
                 <a:solidFill>
                   <a:srgbClr val="A7B3C4"/>
@@ -13458,6 +13682,7 @@
           <a:lstStyle xmlns:a="http://schemas.openxmlformats.org/drawingml/2006/main"/>
           <a:p xmlns:a="http://schemas.openxmlformats.org/drawingml/2006/main">
             <a:pPr algn="l">
+              <a:buNone/>
               <a:defRPr sz="1725" b="1">
                 <a:solidFill>
                   <a:srgbClr val="F4F7FB"/>
@@ -13515,6 +13740,7 @@
           <a:lstStyle xmlns:a="http://schemas.openxmlformats.org/drawingml/2006/main"/>
           <a:p xmlns:a="http://schemas.openxmlformats.org/drawingml/2006/main">
             <a:pPr algn="l">
+              <a:buNone/>
               <a:defRPr sz="1350" b="0">
                 <a:solidFill>
                   <a:srgbClr val="A7B3C4"/>
@@ -13605,6 +13831,7 @@
           <a:lstStyle xmlns:a="http://schemas.openxmlformats.org/drawingml/2006/main"/>
           <a:p xmlns:a="http://schemas.openxmlformats.org/drawingml/2006/main">
             <a:pPr algn="l">
+              <a:buNone/>
               <a:defRPr sz="1725" b="1">
                 <a:solidFill>
                   <a:srgbClr val="F4F7FB"/>
@@ -13662,6 +13889,7 @@
           <a:lstStyle xmlns:a="http://schemas.openxmlformats.org/drawingml/2006/main"/>
           <a:p xmlns:a="http://schemas.openxmlformats.org/drawingml/2006/main">
             <a:pPr algn="l">
+              <a:buNone/>
               <a:defRPr sz="1350" b="0">
                 <a:solidFill>
                   <a:srgbClr val="A7B3C4"/>
@@ -13752,6 +13980,7 @@
           <a:lstStyle xmlns:a="http://schemas.openxmlformats.org/drawingml/2006/main"/>
           <a:p xmlns:a="http://schemas.openxmlformats.org/drawingml/2006/main">
             <a:pPr algn="l">
+              <a:buNone/>
               <a:defRPr sz="1725" b="1">
                 <a:solidFill>
                   <a:srgbClr val="F4F7FB"/>
@@ -13809,6 +14038,7 @@
           <a:lstStyle xmlns:a="http://schemas.openxmlformats.org/drawingml/2006/main"/>
           <a:p xmlns:a="http://schemas.openxmlformats.org/drawingml/2006/main">
             <a:pPr algn="l">
+              <a:buNone/>
               <a:defRPr sz="1350" b="0">
                 <a:solidFill>
                   <a:srgbClr val="A7B3C4"/>
@@ -13827,7 +14057,7 @@
                 <a:ea typeface="Helvetica Neue"/>
                 <a:cs typeface="Helvetica Neue"/>
               </a:rPr>
-              <a:t>Giữ các từ phủ định có ảnh hưởng đến sắc thái.</a:t>
+              <a:t>Giữ từ phủ định và từ chỉ mức độ như “thấp”, “nhiều”.</a:t>
             </a:r>
           </a:p>
         </p:txBody>
@@ -13901,6 +14131,7 @@
           <a:lstStyle xmlns:a="http://schemas.openxmlformats.org/drawingml/2006/main"/>
           <a:p xmlns:a="http://schemas.openxmlformats.org/drawingml/2006/main">
             <a:pPr algn="l">
+              <a:buNone/>
               <a:defRPr sz="1050" b="1">
                 <a:solidFill>
                   <a:srgbClr val="FF667B"/>
@@ -13958,6 +14189,7 @@
           <a:lstStyle xmlns:a="http://schemas.openxmlformats.org/drawingml/2006/main"/>
           <a:p xmlns:a="http://schemas.openxmlformats.org/drawingml/2006/main">
             <a:pPr algn="l">
+              <a:buNone/>
               <a:defRPr sz="1725" b="0">
                 <a:solidFill>
                   <a:srgbClr val="F4F7FB"/>
@@ -14046,6 +14278,7 @@
           <a:lstStyle xmlns:a="http://schemas.openxmlformats.org/drawingml/2006/main"/>
           <a:p xmlns:a="http://schemas.openxmlformats.org/drawingml/2006/main">
             <a:pPr algn="l">
+              <a:buNone/>
               <a:defRPr sz="1050" b="1">
                 <a:solidFill>
                   <a:srgbClr val="45D9A0"/>
@@ -14103,6 +14336,7 @@
           <a:lstStyle xmlns:a="http://schemas.openxmlformats.org/drawingml/2006/main"/>
           <a:p xmlns:a="http://schemas.openxmlformats.org/drawingml/2006/main">
             <a:pPr algn="l">
+              <a:buNone/>
               <a:defRPr sz="1725" b="1">
                 <a:solidFill>
                   <a:srgbClr val="45D9A0"/>
@@ -14121,7 +14355,7 @@
                 <a:ea typeface="Helvetica Neue"/>
                 <a:cs typeface="Helvetica Neue"/>
               </a:rPr>
-              <a:t>lương quản lý minh bạch xuyên không lương</a:t>
+              <a:t>lương thấp quản_lý thiếu minh_bạch thường_xuyên ot không lương</a:t>
             </a:r>
           </a:p>
         </p:txBody>
@@ -14160,6 +14394,7 @@
           <a:lstStyle xmlns:a="http://schemas.openxmlformats.org/drawingml/2006/main"/>
           <a:p xmlns:a="http://schemas.openxmlformats.org/drawingml/2006/main">
             <a:pPr algn="l">
+              <a:buNone/>
               <a:defRPr sz="1200" b="0">
                 <a:solidFill>
                   <a:srgbClr val="A7B3C4"/>
@@ -14178,7 +14413,7 @@
                 <a:ea typeface="Helvetica Neue"/>
                 <a:cs typeface="Helvetica Neue"/>
               </a:rPr>
-              <a:t>Ví dụ được kiểm chứng bằng đúng pipeline triển khai hiện tại.</a:t>
+              <a:t>Ví dụ chạy trên pipeline và model bản sửa hiện tại.</a:t>
             </a:r>
           </a:p>
         </p:txBody>
@@ -14217,6 +14452,7 @@
           <a:lstStyle xmlns:a="http://schemas.openxmlformats.org/drawingml/2006/main"/>
           <a:p xmlns:a="http://schemas.openxmlformats.org/drawingml/2006/main">
             <a:pPr algn="l">
+              <a:buNone/>
               <a:defRPr sz="1350" b="0">
                 <a:solidFill>
                   <a:srgbClr val="A7B3C4"/>
@@ -14303,6 +14539,7 @@
           <a:lstStyle xmlns:a="http://schemas.openxmlformats.org/drawingml/2006/main"/>
           <a:p xmlns:a="http://schemas.openxmlformats.org/drawingml/2006/main">
             <a:pPr algn="l">
+              <a:buNone/>
               <a:defRPr sz="1050" b="1">
                 <a:solidFill>
                   <a:srgbClr val="78A7FF"/>
@@ -14360,6 +14597,7 @@
           <a:lstStyle xmlns:a="http://schemas.openxmlformats.org/drawingml/2006/main"/>
           <a:p xmlns:a="http://schemas.openxmlformats.org/drawingml/2006/main">
             <a:pPr algn="l">
+              <a:buNone/>
               <a:defRPr sz="3150" b="1">
                 <a:solidFill>
                   <a:srgbClr val="F4F7FB"/>
@@ -14448,6 +14686,7 @@
           <a:lstStyle xmlns:a="http://schemas.openxmlformats.org/drawingml/2006/main"/>
           <a:p xmlns:a="http://schemas.openxmlformats.org/drawingml/2006/main">
             <a:pPr algn="r">
+              <a:buNone/>
               <a:defRPr sz="900" b="0">
                 <a:solidFill>
                   <a:srgbClr val="A7B3C4"/>
@@ -14473,14 +14712,14 @@
       </p:sp>
       <p:pic>
         <p:nvPicPr>
-          <p:cNvPr id="17" name=""/>
+          <p:cNvPr id="19" name=""/>
           <p:cNvPicPr>
             <a:picLocks xmlns:a="http://schemas.openxmlformats.org/drawingml/2006/main" noChangeAspect="1"/>
           </p:cNvPicPr>
           <p:nvPr/>
         </p:nvPicPr>
         <p:blipFill>
-          <a:blip xmlns:r="http://schemas.openxmlformats.org/officeDocument/2006/relationships" xmlns:a="http://schemas.openxmlformats.org/drawingml/2006/main" r:embed="R24c4fc687c6a45b2"/>
+          <a:blip xmlns:r="http://schemas.openxmlformats.org/officeDocument/2006/relationships" xmlns:a="http://schemas.openxmlformats.org/drawingml/2006/main" r:embed="Rf3f4e884f7034a0a"/>
           <a:stretch xmlns:a="http://schemas.openxmlformats.org/drawingml/2006/main"/>
         </p:blipFill>
         <p:spPr>
@@ -14527,6 +14766,7 @@
           <a:lstStyle xmlns:a="http://schemas.openxmlformats.org/drawingml/2006/main"/>
           <a:p xmlns:a="http://schemas.openxmlformats.org/drawingml/2006/main">
             <a:pPr algn="l">
+              <a:buNone/>
               <a:defRPr sz="975" b="1">
                 <a:solidFill>
                   <a:srgbClr val="45D9A0"/>
@@ -14584,6 +14824,7 @@
           <a:lstStyle xmlns:a="http://schemas.openxmlformats.org/drawingml/2006/main"/>
           <a:p xmlns:a="http://schemas.openxmlformats.org/drawingml/2006/main">
             <a:pPr algn="l">
+              <a:buNone/>
               <a:defRPr sz="2850" b="1">
                 <a:solidFill>
                   <a:srgbClr val="F4F7FB"/>
@@ -14641,6 +14882,7 @@
           <a:lstStyle xmlns:a="http://schemas.openxmlformats.org/drawingml/2006/main"/>
           <a:p xmlns:a="http://schemas.openxmlformats.org/drawingml/2006/main">
             <a:pPr algn="l">
+              <a:buNone/>
               <a:defRPr sz="975" b="1">
                 <a:solidFill>
                   <a:srgbClr val="78A7FF"/>
@@ -14698,6 +14940,7 @@
           <a:lstStyle xmlns:a="http://schemas.openxmlformats.org/drawingml/2006/main"/>
           <a:p xmlns:a="http://schemas.openxmlformats.org/drawingml/2006/main">
             <a:pPr algn="l">
+              <a:buNone/>
               <a:defRPr sz="2850" b="1">
                 <a:solidFill>
                   <a:srgbClr val="F4F7FB"/>
@@ -14755,6 +14998,7 @@
           <a:lstStyle xmlns:a="http://schemas.openxmlformats.org/drawingml/2006/main"/>
           <a:p xmlns:a="http://schemas.openxmlformats.org/drawingml/2006/main">
             <a:pPr algn="l">
+              <a:buNone/>
               <a:defRPr sz="975" b="1">
                 <a:solidFill>
                   <a:srgbClr val="F4D35E"/>
@@ -14812,6 +15056,7 @@
           <a:lstStyle xmlns:a="http://schemas.openxmlformats.org/drawingml/2006/main"/>
           <a:p xmlns:a="http://schemas.openxmlformats.org/drawingml/2006/main">
             <a:pPr algn="l">
+              <a:buNone/>
               <a:defRPr sz="2850" b="1">
                 <a:solidFill>
                   <a:srgbClr val="F4F7FB"/>
@@ -14869,6 +15114,7 @@
           <a:lstStyle xmlns:a="http://schemas.openxmlformats.org/drawingml/2006/main"/>
           <a:p xmlns:a="http://schemas.openxmlformats.org/drawingml/2006/main">
             <a:pPr algn="l">
+              <a:buNone/>
               <a:defRPr sz="1500" b="0">
                 <a:solidFill>
                   <a:srgbClr val="A7B3C4"/>
@@ -14955,6 +15201,7 @@
           <a:lstStyle xmlns:a="http://schemas.openxmlformats.org/drawingml/2006/main"/>
           <a:p xmlns:a="http://schemas.openxmlformats.org/drawingml/2006/main">
             <a:pPr algn="l">
+              <a:buNone/>
               <a:defRPr sz="1050" b="1">
                 <a:solidFill>
                   <a:srgbClr val="78A7FF"/>
@@ -15012,6 +15259,7 @@
           <a:lstStyle xmlns:a="http://schemas.openxmlformats.org/drawingml/2006/main"/>
           <a:p xmlns:a="http://schemas.openxmlformats.org/drawingml/2006/main">
             <a:pPr algn="l">
+              <a:buNone/>
               <a:defRPr sz="3150" b="1">
                 <a:solidFill>
                   <a:srgbClr val="F4F7FB"/>
@@ -15100,6 +15348,7 @@
           <a:lstStyle xmlns:a="http://schemas.openxmlformats.org/drawingml/2006/main"/>
           <a:p xmlns:a="http://schemas.openxmlformats.org/drawingml/2006/main">
             <a:pPr algn="r">
+              <a:buNone/>
               <a:defRPr sz="900" b="0">
                 <a:solidFill>
                   <a:srgbClr val="A7B3C4"/>
@@ -15125,7 +15374,7 @@
       </p:sp>
       <p:graphicFrame>
         <p:nvGraphicFramePr>
-          <p:cNvPr id="24" name="Chart"/>
+          <p:cNvPr id="26" name="Chart"/>
           <p:cNvGraphicFramePr/>
           <p:nvPr/>
         </p:nvGraphicFramePr>
@@ -15135,7 +15384,7 @@
         </p:xfrm>
         <a:graphic xmlns:a="http://schemas.openxmlformats.org/drawingml/2006/main">
           <a:graphicData uri="http://schemas.openxmlformats.org/drawingml/2006/chart">
-            <c:chart xmlns:r="http://schemas.openxmlformats.org/officeDocument/2006/relationships" xmlns:c="http://schemas.openxmlformats.org/drawingml/2006/chart" r:id="R480fe374566c4e0a"/>
+            <c:chart xmlns:r="http://schemas.openxmlformats.org/officeDocument/2006/relationships" xmlns:c="http://schemas.openxmlformats.org/drawingml/2006/chart" r:id="Rb17d24a0874d4fb8"/>
           </a:graphicData>
         </a:graphic>
       </p:graphicFrame>
@@ -15173,6 +15422,7 @@
           <a:lstStyle xmlns:a="http://schemas.openxmlformats.org/drawingml/2006/main"/>
           <a:p xmlns:a="http://schemas.openxmlformats.org/drawingml/2006/main">
             <a:pPr algn="r">
+              <a:buNone/>
               <a:defRPr sz="900" b="1">
                 <a:solidFill>
                   <a:srgbClr val="A7B3C4"/>
@@ -15263,6 +15513,7 @@
           <a:lstStyle xmlns:a="http://schemas.openxmlformats.org/drawingml/2006/main"/>
           <a:p xmlns:a="http://schemas.openxmlformats.org/drawingml/2006/main">
             <a:pPr algn="l">
+              <a:buNone/>
               <a:defRPr sz="1650" b="1">
                 <a:solidFill>
                   <a:srgbClr val="F4F7FB"/>
@@ -15320,6 +15571,7 @@
           <a:lstStyle xmlns:a="http://schemas.openxmlformats.org/drawingml/2006/main"/>
           <a:p xmlns:a="http://schemas.openxmlformats.org/drawingml/2006/main">
             <a:pPr algn="l">
+              <a:buNone/>
               <a:defRPr sz="1275" b="0">
                 <a:solidFill>
                   <a:srgbClr val="A7B3C4"/>
@@ -15410,6 +15662,7 @@
           <a:lstStyle xmlns:a="http://schemas.openxmlformats.org/drawingml/2006/main"/>
           <a:p xmlns:a="http://schemas.openxmlformats.org/drawingml/2006/main">
             <a:pPr algn="l">
+              <a:buNone/>
               <a:defRPr sz="1650" b="1">
                 <a:solidFill>
                   <a:srgbClr val="F4F7FB"/>
@@ -15467,6 +15720,7 @@
           <a:lstStyle xmlns:a="http://schemas.openxmlformats.org/drawingml/2006/main"/>
           <a:p xmlns:a="http://schemas.openxmlformats.org/drawingml/2006/main">
             <a:pPr algn="l">
+              <a:buNone/>
               <a:defRPr sz="1275" b="0">
                 <a:solidFill>
                   <a:srgbClr val="A7B3C4"/>
@@ -15557,6 +15811,7 @@
           <a:lstStyle xmlns:a="http://schemas.openxmlformats.org/drawingml/2006/main"/>
           <a:p xmlns:a="http://schemas.openxmlformats.org/drawingml/2006/main">
             <a:pPr algn="l">
+              <a:buNone/>
               <a:defRPr sz="1650" b="1">
                 <a:solidFill>
                   <a:srgbClr val="F4F7FB"/>
@@ -15614,6 +15869,7 @@
           <a:lstStyle xmlns:a="http://schemas.openxmlformats.org/drawingml/2006/main"/>
           <a:p xmlns:a="http://schemas.openxmlformats.org/drawingml/2006/main">
             <a:pPr algn="l">
+              <a:buNone/>
               <a:defRPr sz="1275" b="0">
                 <a:solidFill>
                   <a:srgbClr val="A7B3C4"/>
@@ -15702,6 +15958,7 @@
           <a:lstStyle xmlns:a="http://schemas.openxmlformats.org/drawingml/2006/main"/>
           <a:p xmlns:a="http://schemas.openxmlformats.org/drawingml/2006/main">
             <a:pPr algn="l">
+              <a:buNone/>
               <a:defRPr sz="1500" b="1">
                 <a:solidFill>
                   <a:srgbClr val="F4F7FB"/>
@@ -15759,6 +16016,7 @@
           <a:lstStyle xmlns:a="http://schemas.openxmlformats.org/drawingml/2006/main"/>
           <a:p xmlns:a="http://schemas.openxmlformats.org/drawingml/2006/main">
             <a:pPr algn="l">
+              <a:buNone/>
               <a:defRPr sz="1350" b="0">
                 <a:solidFill>
                   <a:srgbClr val="A7B3C4"/>
@@ -15816,6 +16074,7 @@
           <a:lstStyle xmlns:a="http://schemas.openxmlformats.org/drawingml/2006/main"/>
           <a:p xmlns:a="http://schemas.openxmlformats.org/drawingml/2006/main">
             <a:pPr algn="l">
+              <a:buNone/>
               <a:defRPr sz="1200" b="0">
                 <a:solidFill>
                   <a:srgbClr val="FF9C5A"/>
@@ -15902,6 +16161,7 @@
           <a:lstStyle xmlns:a="http://schemas.openxmlformats.org/drawingml/2006/main"/>
           <a:p xmlns:a="http://schemas.openxmlformats.org/drawingml/2006/main">
             <a:pPr algn="l">
+              <a:buNone/>
               <a:defRPr sz="1050" b="1">
                 <a:solidFill>
                   <a:srgbClr val="78A7FF"/>
@@ -15959,6 +16219,7 @@
           <a:lstStyle xmlns:a="http://schemas.openxmlformats.org/drawingml/2006/main"/>
           <a:p xmlns:a="http://schemas.openxmlformats.org/drawingml/2006/main">
             <a:pPr algn="l">
+              <a:buNone/>
               <a:defRPr sz="3150" b="1">
                 <a:solidFill>
                   <a:srgbClr val="F4F7FB"/>
@@ -16047,6 +16308,7 @@
           <a:lstStyle xmlns:a="http://schemas.openxmlformats.org/drawingml/2006/main"/>
           <a:p xmlns:a="http://schemas.openxmlformats.org/drawingml/2006/main">
             <a:pPr algn="r">
+              <a:buNone/>
               <a:defRPr sz="900" b="0">
                 <a:solidFill>
                   <a:srgbClr val="A7B3C4"/>
@@ -16104,6 +16366,7 @@
           <a:lstStyle xmlns:a="http://schemas.openxmlformats.org/drawingml/2006/main"/>
           <a:p xmlns:a="http://schemas.openxmlformats.org/drawingml/2006/main">
             <a:pPr algn="l">
+              <a:buNone/>
               <a:defRPr sz="1350" b="1">
                 <a:solidFill>
                   <a:srgbClr val="78A7FF"/>
@@ -16161,6 +16424,7 @@
           <a:lstStyle xmlns:a="http://schemas.openxmlformats.org/drawingml/2006/main"/>
           <a:p xmlns:a="http://schemas.openxmlformats.org/drawingml/2006/main">
             <a:pPr algn="l">
+              <a:buNone/>
               <a:defRPr sz="1575" b="1">
                 <a:solidFill>
                   <a:srgbClr val="F4F7FB"/>
@@ -16218,6 +16482,7 @@
           <a:lstStyle xmlns:a="http://schemas.openxmlformats.org/drawingml/2006/main"/>
           <a:p xmlns:a="http://schemas.openxmlformats.org/drawingml/2006/main">
             <a:pPr algn="l">
+              <a:buNone/>
               <a:defRPr sz="1350" b="1">
                 <a:solidFill>
                   <a:srgbClr val="45D9A0"/>
@@ -16275,6 +16540,7 @@
           <a:lstStyle xmlns:a="http://schemas.openxmlformats.org/drawingml/2006/main"/>
           <a:p xmlns:a="http://schemas.openxmlformats.org/drawingml/2006/main">
             <a:pPr algn="l">
+              <a:buNone/>
               <a:defRPr sz="1575" b="1">
                 <a:solidFill>
                   <a:srgbClr val="F4F7FB"/>
@@ -16332,6 +16598,7 @@
           <a:lstStyle xmlns:a="http://schemas.openxmlformats.org/drawingml/2006/main"/>
           <a:p xmlns:a="http://schemas.openxmlformats.org/drawingml/2006/main">
             <a:pPr algn="l">
+              <a:buNone/>
               <a:defRPr sz="1350" b="1">
                 <a:solidFill>
                   <a:srgbClr val="F4D35E"/>
@@ -16389,6 +16656,7 @@
           <a:lstStyle xmlns:a="http://schemas.openxmlformats.org/drawingml/2006/main"/>
           <a:p xmlns:a="http://schemas.openxmlformats.org/drawingml/2006/main">
             <a:pPr algn="l">
+              <a:buNone/>
               <a:defRPr sz="1575" b="1">
                 <a:solidFill>
                   <a:srgbClr val="F4F7FB"/>
@@ -16446,6 +16714,7 @@
           <a:lstStyle xmlns:a="http://schemas.openxmlformats.org/drawingml/2006/main"/>
           <a:p xmlns:a="http://schemas.openxmlformats.org/drawingml/2006/main">
             <a:pPr algn="l">
+              <a:buNone/>
               <a:defRPr sz="1350" b="1">
                 <a:solidFill>
                   <a:srgbClr val="FF9C5A"/>
@@ -16503,6 +16772,7 @@
           <a:lstStyle xmlns:a="http://schemas.openxmlformats.org/drawingml/2006/main"/>
           <a:p xmlns:a="http://schemas.openxmlformats.org/drawingml/2006/main">
             <a:pPr algn="l">
+              <a:buNone/>
               <a:defRPr sz="1575" b="1">
                 <a:solidFill>
                   <a:srgbClr val="F4F7FB"/>
@@ -16560,6 +16830,7 @@
           <a:lstStyle xmlns:a="http://schemas.openxmlformats.org/drawingml/2006/main"/>
           <a:p xmlns:a="http://schemas.openxmlformats.org/drawingml/2006/main">
             <a:pPr algn="l">
+              <a:buNone/>
               <a:defRPr sz="1350" b="1">
                 <a:solidFill>
                   <a:srgbClr val="FF667B"/>
@@ -16617,6 +16888,7 @@
           <a:lstStyle xmlns:a="http://schemas.openxmlformats.org/drawingml/2006/main"/>
           <a:p xmlns:a="http://schemas.openxmlformats.org/drawingml/2006/main">
             <a:pPr algn="l">
+              <a:buNone/>
               <a:defRPr sz="1575" b="1">
                 <a:solidFill>
                   <a:srgbClr val="F4F7FB"/>
@@ -16705,6 +16977,7 @@
           <a:lstStyle xmlns:a="http://schemas.openxmlformats.org/drawingml/2006/main"/>
           <a:p xmlns:a="http://schemas.openxmlformats.org/drawingml/2006/main">
             <a:pPr algn="l">
+              <a:buNone/>
               <a:defRPr sz="2250" b="1">
                 <a:solidFill>
                   <a:srgbClr val="F4F7FB"/>
@@ -16797,6 +17070,7 @@
           <a:lstStyle xmlns:a="http://schemas.openxmlformats.org/drawingml/2006/main"/>
           <a:p xmlns:a="http://schemas.openxmlformats.org/drawingml/2006/main">
             <a:pPr algn="l">
+              <a:buNone/>
               <a:defRPr sz="1575" b="1">
                 <a:solidFill>
                   <a:srgbClr val="78A7FF"/>
@@ -16854,6 +17128,7 @@
           <a:lstStyle xmlns:a="http://schemas.openxmlformats.org/drawingml/2006/main"/>
           <a:p xmlns:a="http://schemas.openxmlformats.org/drawingml/2006/main">
             <a:pPr algn="l">
+              <a:buNone/>
               <a:defRPr sz="1200" b="0">
                 <a:solidFill>
                   <a:srgbClr val="A7B3C4"/>
@@ -16946,6 +17221,7 @@
           <a:lstStyle xmlns:a="http://schemas.openxmlformats.org/drawingml/2006/main"/>
           <a:p xmlns:a="http://schemas.openxmlformats.org/drawingml/2006/main">
             <a:pPr algn="l">
+              <a:buNone/>
               <a:defRPr sz="1575" b="1">
                 <a:solidFill>
                   <a:srgbClr val="FF9C5A"/>
@@ -17003,6 +17279,7 @@
           <a:lstStyle xmlns:a="http://schemas.openxmlformats.org/drawingml/2006/main"/>
           <a:p xmlns:a="http://schemas.openxmlformats.org/drawingml/2006/main">
             <a:pPr algn="l">
+              <a:buNone/>
               <a:defRPr sz="1200" b="0">
                 <a:solidFill>
                   <a:srgbClr val="A7B3C4"/>
@@ -17095,6 +17372,7 @@
           <a:lstStyle xmlns:a="http://schemas.openxmlformats.org/drawingml/2006/main"/>
           <a:p xmlns:a="http://schemas.openxmlformats.org/drawingml/2006/main">
             <a:pPr algn="l">
+              <a:buNone/>
               <a:defRPr sz="1575" b="1">
                 <a:solidFill>
                   <a:srgbClr val="45D9A0"/>
@@ -17152,6 +17430,7 @@
           <a:lstStyle xmlns:a="http://schemas.openxmlformats.org/drawingml/2006/main"/>
           <a:p xmlns:a="http://schemas.openxmlformats.org/drawingml/2006/main">
             <a:pPr algn="l">
+              <a:buNone/>
               <a:defRPr sz="1200" b="0">
                 <a:solidFill>
                   <a:srgbClr val="A7B3C4"/>
@@ -17244,6 +17523,7 @@
           <a:lstStyle xmlns:a="http://schemas.openxmlformats.org/drawingml/2006/main"/>
           <a:p xmlns:a="http://schemas.openxmlformats.org/drawingml/2006/main">
             <a:pPr algn="l">
+              <a:buNone/>
               <a:defRPr sz="1575" b="1">
                 <a:solidFill>
                   <a:srgbClr val="F4D35E"/>
@@ -17301,6 +17581,7 @@
           <a:lstStyle xmlns:a="http://schemas.openxmlformats.org/drawingml/2006/main"/>
           <a:p xmlns:a="http://schemas.openxmlformats.org/drawingml/2006/main">
             <a:pPr algn="l">
+              <a:buNone/>
               <a:defRPr sz="1200" b="0">
                 <a:solidFill>
                   <a:srgbClr val="A7B3C4"/>
@@ -17326,7 +17607,7 @@
       </p:sp>
       <p:cxnSp>
         <p:nvCxnSpPr>
-          <p:cNvPr id="61" name=""/>
+          <p:cNvPr id="123" name=""/>
           <p:cNvCxnSpPr>
             <a:stCxn xmlns:a="http://schemas.openxmlformats.org/drawingml/2006/main" id="17" idx="3"/>
             <a:endCxn xmlns:a="http://schemas.openxmlformats.org/drawingml/2006/main" id="20" idx="1"/>
@@ -17352,7 +17633,7 @@
       </p:cxnSp>
       <p:cxnSp>
         <p:nvCxnSpPr>
-          <p:cNvPr id="62" name=""/>
+          <p:cNvPr id="124" name=""/>
           <p:cNvCxnSpPr>
             <a:stCxn xmlns:a="http://schemas.openxmlformats.org/drawingml/2006/main" id="20" idx="3"/>
             <a:endCxn xmlns:a="http://schemas.openxmlformats.org/drawingml/2006/main" id="23" idx="1"/>
@@ -17378,7 +17659,7 @@
       </p:cxnSp>
       <p:cxnSp>
         <p:nvCxnSpPr>
-          <p:cNvPr id="63" name=""/>
+          <p:cNvPr id="125" name=""/>
           <p:cNvCxnSpPr>
             <a:stCxn xmlns:a="http://schemas.openxmlformats.org/drawingml/2006/main" id="23" idx="3"/>
             <a:endCxn xmlns:a="http://schemas.openxmlformats.org/drawingml/2006/main" id="26" idx="1"/>
@@ -17436,6 +17717,7 @@
           <a:lstStyle xmlns:a="http://schemas.openxmlformats.org/drawingml/2006/main"/>
           <a:p xmlns:a="http://schemas.openxmlformats.org/drawingml/2006/main">
             <a:pPr algn="l">
+              <a:buNone/>
               <a:defRPr sz="1500" b="0">
                 <a:solidFill>
                   <a:srgbClr val="A7B3C4"/>
@@ -17522,6 +17804,7 @@
           <a:lstStyle xmlns:a="http://schemas.openxmlformats.org/drawingml/2006/main"/>
           <a:p xmlns:a="http://schemas.openxmlformats.org/drawingml/2006/main">
             <a:pPr algn="l">
+              <a:buNone/>
               <a:defRPr sz="1050" b="1">
                 <a:solidFill>
                   <a:srgbClr val="78A7FF"/>
@@ -17574,11 +17857,12 @@
         </p:spPr>
         <p:txBody>
           <a:bodyPr xmlns:a="http://schemas.openxmlformats.org/drawingml/2006/main" anchor="t">
-            <a:normAutofit fontScale="97820"/>
-          </a:bodyPr>
-          <a:lstStyle xmlns:a="http://schemas.openxmlformats.org/drawingml/2006/main"/>
-          <a:p xmlns:a="http://schemas.openxmlformats.org/drawingml/2006/main">
-            <a:pPr algn="l">
+            <a:normAutofit fontScale="100000"/>
+          </a:bodyPr>
+          <a:lstStyle xmlns:a="http://schemas.openxmlformats.org/drawingml/2006/main"/>
+          <a:p xmlns:a="http://schemas.openxmlformats.org/drawingml/2006/main">
+            <a:pPr algn="l">
+              <a:buNone/>
               <a:defRPr sz="3150" b="1">
                 <a:solidFill>
                   <a:srgbClr val="F4F7FB"/>
@@ -17597,7 +17881,7 @@
                 <a:ea typeface="Helvetica Neue"/>
                 <a:cs typeface="Helvetica Neue"/>
               </a:rPr>
-              <a:t>Logistic Regression và Linear SVM gần như ngang nhau</a:t>
+              <a:t>Xếp hạng gốc; Logistic Regression cải thiện sau sửa lỗi</a:t>
             </a:r>
           </a:p>
         </p:txBody>
@@ -17667,6 +17951,7 @@
           <a:lstStyle xmlns:a="http://schemas.openxmlformats.org/drawingml/2006/main"/>
           <a:p xmlns:a="http://schemas.openxmlformats.org/drawingml/2006/main">
             <a:pPr algn="r">
+              <a:buNone/>
               <a:defRPr sz="900" b="0">
                 <a:solidFill>
                   <a:srgbClr val="A7B3C4"/>
@@ -17692,7 +17977,7 @@
       </p:sp>
       <p:graphicFrame>
         <p:nvGraphicFramePr>
-          <p:cNvPr id="23" name="Chart"/>
+          <p:cNvPr id="25" name="Chart"/>
           <p:cNvGraphicFramePr/>
           <p:nvPr/>
         </p:nvGraphicFramePr>
@@ -17702,7 +17987,7 @@
         </p:xfrm>
         <a:graphic xmlns:a="http://schemas.openxmlformats.org/drawingml/2006/main">
           <a:graphicData uri="http://schemas.openxmlformats.org/drawingml/2006/chart">
-            <c:chart xmlns:r="http://schemas.openxmlformats.org/officeDocument/2006/relationships" xmlns:c="http://schemas.openxmlformats.org/drawingml/2006/chart" r:id="Rf75e587044bc4591"/>
+            <c:chart xmlns:r="http://schemas.openxmlformats.org/officeDocument/2006/relationships" xmlns:c="http://schemas.openxmlformats.org/drawingml/2006/chart" r:id="Re88c139d27314149"/>
           </a:graphicData>
         </a:graphic>
       </p:graphicFrame>
@@ -17740,6 +18025,7 @@
           <a:lstStyle xmlns:a="http://schemas.openxmlformats.org/drawingml/2006/main"/>
           <a:p xmlns:a="http://schemas.openxmlformats.org/drawingml/2006/main">
             <a:pPr algn="r">
+              <a:buNone/>
               <a:defRPr sz="900" b="1">
                 <a:solidFill>
                   <a:srgbClr val="A7B3C4"/>
@@ -17797,6 +18083,7 @@
           <a:lstStyle xmlns:a="http://schemas.openxmlformats.org/drawingml/2006/main"/>
           <a:p xmlns:a="http://schemas.openxmlformats.org/drawingml/2006/main">
             <a:pPr algn="l">
+              <a:buNone/>
               <a:defRPr sz="975" b="1">
                 <a:solidFill>
                   <a:srgbClr val="F4D35E"/>
@@ -17854,6 +18141,7 @@
           <a:lstStyle xmlns:a="http://schemas.openxmlformats.org/drawingml/2006/main"/>
           <a:p xmlns:a="http://schemas.openxmlformats.org/drawingml/2006/main">
             <a:pPr algn="l">
+              <a:buNone/>
               <a:defRPr sz="2850" b="1">
                 <a:solidFill>
                   <a:srgbClr val="F4F7FB"/>
@@ -17911,6 +18199,7 @@
           <a:lstStyle xmlns:a="http://schemas.openxmlformats.org/drawingml/2006/main"/>
           <a:p xmlns:a="http://schemas.openxmlformats.org/drawingml/2006/main">
             <a:pPr algn="l">
+              <a:buNone/>
               <a:defRPr sz="1800" b="1">
                 <a:solidFill>
                   <a:srgbClr val="45D9A0"/>
@@ -17929,7 +18218,7 @@
                 <a:ea typeface="Helvetica Neue"/>
                 <a:cs typeface="Helvetica Neue"/>
               </a:rPr>
-              <a:t>Chọn Logistic Regression</a:t>
+              <a:t>Model được triển khai</a:t>
             </a:r>
           </a:p>
         </p:txBody>
@@ -18001,6 +18290,7 @@
           <a:lstStyle xmlns:a="http://schemas.openxmlformats.org/drawingml/2006/main"/>
           <a:p xmlns:a="http://schemas.openxmlformats.org/drawingml/2006/main">
             <a:pPr algn="l">
+              <a:buNone/>
               <a:defRPr sz="1425" b="1">
                 <a:solidFill>
                   <a:srgbClr val="F4F7FB"/>
@@ -18019,7 +18309,7 @@
                 <a:ea typeface="Helvetica Neue"/>
                 <a:cs typeface="Helvetica Neue"/>
               </a:rPr>
-              <a:t>CV Macro F1 cao nhất</a:t>
+              <a:t>Bảng 5 model ban đầu</a:t>
             </a:r>
           </a:p>
         </p:txBody>
@@ -18058,6 +18348,7 @@
           <a:lstStyle xmlns:a="http://schemas.openxmlformats.org/drawingml/2006/main"/>
           <a:p xmlns:a="http://schemas.openxmlformats.org/drawingml/2006/main">
             <a:pPr algn="l">
+              <a:buNone/>
               <a:defRPr sz="1200" b="0">
                 <a:solidFill>
                   <a:srgbClr val="A7B3C4"/>
@@ -18076,7 +18367,7 @@
                 <a:ea typeface="Helvetica Neue"/>
                 <a:cs typeface="Helvetica Neue"/>
               </a:rPr>
-              <a:t>0,5727 với C = 1.0 và SMOTE.</a:t>
+              <a:t>LR đạt 0,5727, hơn SVM 0,0003.</a:t>
             </a:r>
           </a:p>
         </p:txBody>
@@ -18148,6 +18439,7 @@
           <a:lstStyle xmlns:a="http://schemas.openxmlformats.org/drawingml/2006/main"/>
           <a:p xmlns:a="http://schemas.openxmlformats.org/drawingml/2006/main">
             <a:pPr algn="l">
+              <a:buNone/>
               <a:defRPr sz="1425" b="1">
                 <a:solidFill>
                   <a:srgbClr val="F4F7FB"/>
@@ -18166,7 +18458,7 @@
                 <a:ea typeface="Helvetica Neue"/>
                 <a:cs typeface="Helvetica Neue"/>
               </a:rPr>
-              <a:t>Có predict_proba</a:t>
+              <a:t>Sau sửa tiền xử lý</a:t>
             </a:r>
           </a:p>
         </p:txBody>
@@ -18205,6 +18497,7 @@
           <a:lstStyle xmlns:a="http://schemas.openxmlformats.org/drawingml/2006/main"/>
           <a:p xmlns:a="http://schemas.openxmlformats.org/drawingml/2006/main">
             <a:pPr algn="l">
+              <a:buNone/>
               <a:defRPr sz="1200" b="0">
                 <a:solidFill>
                   <a:srgbClr val="A7B3C4"/>
@@ -18223,7 +18516,7 @@
                 <a:ea typeface="Helvetica Neue"/>
                 <a:cs typeface="Helvetica Neue"/>
               </a:rPr>
-              <a:t>Phù hợp cho giao diện xác suất của web demo.</a:t>
+              <a:t>CV riêng tăng từ 0,5708 lên 0,5815.</a:t>
             </a:r>
           </a:p>
         </p:txBody>
@@ -18295,6 +18588,7 @@
           <a:lstStyle xmlns:a="http://schemas.openxmlformats.org/drawingml/2006/main"/>
           <a:p xmlns:a="http://schemas.openxmlformats.org/drawingml/2006/main">
             <a:pPr algn="l">
+              <a:buNone/>
               <a:defRPr sz="1425" b="1">
                 <a:solidFill>
                   <a:srgbClr val="F4F7FB"/>
@@ -18313,7 +18607,7 @@
                 <a:ea typeface="Helvetica Neue"/>
                 <a:cs typeface="Helvetica Neue"/>
               </a:rPr>
-              <a:t>Không tuyên bố vượt trội thống kê</a:t>
+              <a:t>Giữ đúng phạm vi so sánh</a:t>
             </a:r>
           </a:p>
         </p:txBody>
@@ -18352,6 +18646,7 @@
           <a:lstStyle xmlns:a="http://schemas.openxmlformats.org/drawingml/2006/main"/>
           <a:p xmlns:a="http://schemas.openxmlformats.org/drawingml/2006/main">
             <a:pPr algn="l">
+              <a:buNone/>
               <a:defRPr sz="1200" b="0">
                 <a:solidFill>
                   <a:srgbClr val="A7B3C4"/>
@@ -18370,7 +18665,7 @@
                 <a:ea typeface="Helvetica Neue"/>
                 <a:cs typeface="Helvetica Neue"/>
               </a:rPr>
-              <a:t>Điểm của LR và SVM quá sát để kết luận chênh lệch đáng kể.</a:t>
+              <a:t>Chưa xếp hạng lại bốn model còn lại.</a:t>
             </a:r>
           </a:p>
         </p:txBody>
@@ -18438,6 +18733,7 @@
           <a:lstStyle xmlns:a="http://schemas.openxmlformats.org/drawingml/2006/main"/>
           <a:p xmlns:a="http://schemas.openxmlformats.org/drawingml/2006/main">
             <a:pPr algn="l">
+              <a:buNone/>
               <a:defRPr sz="1050" b="1">
                 <a:solidFill>
                   <a:srgbClr val="78A7FF"/>
@@ -18495,6 +18791,7 @@
           <a:lstStyle xmlns:a="http://schemas.openxmlformats.org/drawingml/2006/main"/>
           <a:p xmlns:a="http://schemas.openxmlformats.org/drawingml/2006/main">
             <a:pPr algn="l">
+              <a:buNone/>
               <a:defRPr sz="3150" b="1">
                 <a:solidFill>
                   <a:srgbClr val="F4F7FB"/>
@@ -18513,7 +18810,7 @@
                 <a:ea typeface="Helvetica Neue"/>
                 <a:cs typeface="Helvetica Neue"/>
               </a:rPr>
-              <a:t>Macro F1 ổn định nhưng lớp Negative vẫn khó</a:t>
+              <a:t>Bản sửa cải thiện nhẹ; lớp Negative vẫn khó</a:t>
             </a:r>
           </a:p>
         </p:txBody>
@@ -18583,6 +18880,7 @@
           <a:lstStyle xmlns:a="http://schemas.openxmlformats.org/drawingml/2006/main"/>
           <a:p xmlns:a="http://schemas.openxmlformats.org/drawingml/2006/main">
             <a:pPr algn="r">
+              <a:buNone/>
               <a:defRPr sz="900" b="0">
                 <a:solidFill>
                   <a:srgbClr val="A7B3C4"/>
@@ -18640,6 +18938,7 @@
           <a:lstStyle xmlns:a="http://schemas.openxmlformats.org/drawingml/2006/main"/>
           <a:p xmlns:a="http://schemas.openxmlformats.org/drawingml/2006/main">
             <a:pPr algn="l">
+              <a:buNone/>
               <a:defRPr sz="975" b="1">
                 <a:solidFill>
                   <a:srgbClr val="78A7FF"/>
@@ -18697,6 +18996,7 @@
           <a:lstStyle xmlns:a="http://schemas.openxmlformats.org/drawingml/2006/main"/>
           <a:p xmlns:a="http://schemas.openxmlformats.org/drawingml/2006/main">
             <a:pPr algn="l">
+              <a:buNone/>
               <a:defRPr sz="2850" b="1">
                 <a:solidFill>
                   <a:srgbClr val="F4F7FB"/>
@@ -18715,7 +19015,7 @@
                 <a:ea typeface="Helvetica Neue"/>
                 <a:cs typeface="Helvetica Neue"/>
               </a:rPr>
-              <a:t>73,74%</a:t>
+              <a:t>74,33%</a:t>
             </a:r>
           </a:p>
         </p:txBody>
@@ -18754,6 +19054,7 @@
           <a:lstStyle xmlns:a="http://schemas.openxmlformats.org/drawingml/2006/main"/>
           <a:p xmlns:a="http://schemas.openxmlformats.org/drawingml/2006/main">
             <a:pPr algn="l">
+              <a:buNone/>
               <a:defRPr sz="975" b="1">
                 <a:solidFill>
                   <a:srgbClr val="45D9A0"/>
@@ -18811,6 +19112,7 @@
           <a:lstStyle xmlns:a="http://schemas.openxmlformats.org/drawingml/2006/main"/>
           <a:p xmlns:a="http://schemas.openxmlformats.org/drawingml/2006/main">
             <a:pPr algn="l">
+              <a:buNone/>
               <a:defRPr sz="2850" b="1">
                 <a:solidFill>
                   <a:srgbClr val="F4F7FB"/>
@@ -18829,7 +19131,7 @@
                 <a:ea typeface="Helvetica Neue"/>
                 <a:cs typeface="Helvetica Neue"/>
               </a:rPr>
-              <a:t>0,5714</a:t>
+              <a:t>0,5764</a:t>
             </a:r>
           </a:p>
         </p:txBody>
@@ -18868,6 +19170,7 @@
           <a:lstStyle xmlns:a="http://schemas.openxmlformats.org/drawingml/2006/main"/>
           <a:p xmlns:a="http://schemas.openxmlformats.org/drawingml/2006/main">
             <a:pPr algn="l">
+              <a:buNone/>
               <a:defRPr sz="975" b="1">
                 <a:solidFill>
                   <a:srgbClr val="F4D35E"/>
@@ -18925,6 +19228,7 @@
           <a:lstStyle xmlns:a="http://schemas.openxmlformats.org/drawingml/2006/main"/>
           <a:p xmlns:a="http://schemas.openxmlformats.org/drawingml/2006/main">
             <a:pPr algn="l">
+              <a:buNone/>
               <a:defRPr sz="2850" b="1">
                 <a:solidFill>
                   <a:srgbClr val="F4F7FB"/>
@@ -18943,7 +19247,7 @@
                 <a:ea typeface="Helvetica Neue"/>
                 <a:cs typeface="Helvetica Neue"/>
               </a:rPr>
-              <a:t>0,7489</a:t>
+              <a:t>0,7540</a:t>
             </a:r>
           </a:p>
         </p:txBody>
@@ -18982,6 +19286,7 @@
           <a:lstStyle xmlns:a="http://schemas.openxmlformats.org/drawingml/2006/main"/>
           <a:p xmlns:a="http://schemas.openxmlformats.org/drawingml/2006/main">
             <a:pPr algn="l">
+              <a:buNone/>
               <a:defRPr sz="975" b="1">
                 <a:solidFill>
                   <a:srgbClr val="FF667B"/>
@@ -19039,6 +19344,7 @@
           <a:lstStyle xmlns:a="http://schemas.openxmlformats.org/drawingml/2006/main"/>
           <a:p xmlns:a="http://schemas.openxmlformats.org/drawingml/2006/main">
             <a:pPr algn="l">
+              <a:buNone/>
               <a:defRPr sz="2850" b="1">
                 <a:solidFill>
                   <a:srgbClr val="F4F7FB"/>
@@ -19057,14 +19363,14 @@
                 <a:ea typeface="Helvetica Neue"/>
                 <a:cs typeface="Helvetica Neue"/>
               </a:rPr>
-              <a:t>442 / 1.683</a:t>
+              <a:t>432 / 1.683</a:t>
             </a:r>
           </a:p>
         </p:txBody>
       </p:sp>
       <p:graphicFrame>
         <p:nvGraphicFramePr>
-          <p:cNvPr id="29" name=""/>
+          <p:cNvPr id="32" name=""/>
           <p:cNvGraphicFramePr/>
           <p:nvPr/>
         </p:nvGraphicFramePr>
@@ -19219,7 +19525,7 @@
                           <a:ea typeface="Helvetica Neue"/>
                           <a:cs typeface="Helvetica Neue"/>
                         </a:rPr>
-                        <a:t>51</a:t>
+                        <a:t>52</a:t>
                       </a:r>
                     </a:p>
                   </a:txBody>
@@ -19243,7 +19549,7 @@
                           <a:ea typeface="Helvetica Neue"/>
                           <a:cs typeface="Helvetica Neue"/>
                         </a:rPr>
-                        <a:t>40</a:t>
+                        <a:t>41</a:t>
                       </a:r>
                     </a:p>
                   </a:txBody>
@@ -19267,7 +19573,7 @@
                           <a:ea typeface="Helvetica Neue"/>
                           <a:cs typeface="Helvetica Neue"/>
                         </a:rPr>
-                        <a:t>23</a:t>
+                        <a:t>21</a:t>
                       </a:r>
                     </a:p>
                   </a:txBody>
@@ -19317,7 +19623,7 @@
                           <a:ea typeface="Helvetica Neue"/>
                           <a:cs typeface="Helvetica Neue"/>
                         </a:rPr>
-                        <a:t>53</a:t>
+                        <a:t>56</a:t>
                       </a:r>
                     </a:p>
                   </a:txBody>
@@ -19341,7 +19647,7 @@
                           <a:ea typeface="Helvetica Neue"/>
                           <a:cs typeface="Helvetica Neue"/>
                         </a:rPr>
-                        <a:t>170</a:t>
+                        <a:t>168</a:t>
                       </a:r>
                     </a:p>
                   </a:txBody>
@@ -19365,7 +19671,7 @@
                           <a:ea typeface="Helvetica Neue"/>
                           <a:cs typeface="Helvetica Neue"/>
                         </a:rPr>
-                        <a:t>105</a:t>
+                        <a:t>104</a:t>
                       </a:r>
                     </a:p>
                   </a:txBody>
@@ -19415,7 +19721,7 @@
                           <a:ea typeface="Helvetica Neue"/>
                           <a:cs typeface="Helvetica Neue"/>
                         </a:rPr>
-                        <a:t>50</a:t>
+                        <a:t>44</a:t>
                       </a:r>
                     </a:p>
                   </a:txBody>
@@ -19439,7 +19745,7 @@
                           <a:ea typeface="Helvetica Neue"/>
                           <a:cs typeface="Helvetica Neue"/>
                         </a:rPr>
-                        <a:t>171</a:t>
+                        <a:t>166</a:t>
                       </a:r>
                     </a:p>
                   </a:txBody>
@@ -19463,7 +19769,7 @@
                           <a:ea typeface="Helvetica Neue"/>
                           <a:cs typeface="Helvetica Neue"/>
                         </a:rPr>
-                        <a:t>1.020</a:t>
+                        <a:t>1.031</a:t>
                       </a:r>
                     </a:p>
                   </a:txBody>
@@ -19480,7 +19786,7 @@
       </p:graphicFrame>
       <p:graphicFrame>
         <p:nvGraphicFramePr>
-          <p:cNvPr id="30" name="Chart"/>
+          <p:cNvPr id="33" name="Chart"/>
           <p:cNvGraphicFramePr/>
           <p:nvPr/>
         </p:nvGraphicFramePr>
@@ -19490,7 +19796,7 @@
         </p:xfrm>
         <a:graphic xmlns:a="http://schemas.openxmlformats.org/drawingml/2006/main">
           <a:graphicData uri="http://schemas.openxmlformats.org/drawingml/2006/chart">
-            <c:chart xmlns:r="http://schemas.openxmlformats.org/officeDocument/2006/relationships" xmlns:c="http://schemas.openxmlformats.org/drawingml/2006/chart" r:id="R3bdb6c4fcc8f4b63"/>
+            <c:chart xmlns:r="http://schemas.openxmlformats.org/officeDocument/2006/relationships" xmlns:c="http://schemas.openxmlformats.org/drawingml/2006/chart" r:id="Rfdddb44e8e944fdc"/>
           </a:graphicData>
         </a:graphic>
       </p:graphicFrame>
@@ -19528,6 +19834,7 @@
           <a:lstStyle xmlns:a="http://schemas.openxmlformats.org/drawingml/2006/main"/>
           <a:p xmlns:a="http://schemas.openxmlformats.org/drawingml/2006/main">
             <a:pPr algn="r">
+              <a:buNone/>
               <a:defRPr sz="900" b="1">
                 <a:solidFill>
                   <a:srgbClr val="A7B3C4"/>
@@ -19585,6 +19892,7 @@
           <a:lstStyle xmlns:a="http://schemas.openxmlformats.org/drawingml/2006/main"/>
           <a:p xmlns:a="http://schemas.openxmlformats.org/drawingml/2006/main">
             <a:pPr algn="l">
+              <a:buNone/>
               <a:defRPr sz="1425" b="0">
                 <a:solidFill>
                   <a:srgbClr val="FF9C5A"/>
@@ -19603,7 +19911,7 @@
                 <a:ea typeface="Helvetica Neue"/>
                 <a:cs typeface="Helvetica Neue"/>
               </a:rPr>
-              <a:t>Accuracy bằng mức của majority baseline, nên Macro F1 và F1 theo lớp mới phản ánh đúng chất lượng mô hình.</a:t>
+              <a:t>Final Test cũ được dùng lại để đối chiếu bản sửa, không phải tập kiểm thử độc lập mới.</a:t>
             </a:r>
           </a:p>
         </p:txBody>

</xml_diff>

<commit_message>
docs(slides): refine ML presentation and live walkthrough
</commit_message>
<xml_diff>
--- a/reports/slides/ITviec_Sentiment_Analysis.pptx
+++ b/reports/slides/ITviec_Sentiment_Analysis.pptx
@@ -2,27 +2,27 @@
 <file path=ppt/presentation.xml><?xml version="1.0" encoding="utf-8"?>
 <p:presentation xmlns:p="http://schemas.openxmlformats.org/presentationml/2006/main">
   <p:sldMasterIdLst>
-    <p:sldMasterId xmlns:r="http://schemas.openxmlformats.org/officeDocument/2006/relationships" id="2147483648" r:id="Rd35db0d22386409d"/>
+    <p:sldMasterId xmlns:r="http://schemas.openxmlformats.org/officeDocument/2006/relationships" id="2147483648" r:id="Rb640ac4891e74163"/>
   </p:sldMasterIdLst>
   <p:notesMasterIdLst>
-    <p:notesMasterId xmlns:r="http://schemas.openxmlformats.org/officeDocument/2006/relationships" r:id="Rf9ab59980ceb4569"/>
+    <p:notesMasterId xmlns:r="http://schemas.openxmlformats.org/officeDocument/2006/relationships" r:id="Rb924613fcd154621"/>
   </p:notesMasterIdLst>
   <p:sldIdLst>
-    <p:sldId xmlns:r="http://schemas.openxmlformats.org/officeDocument/2006/relationships" id="256" r:id="Ra35b33c4dafd4abc"/>
-    <p:sldId xmlns:r="http://schemas.openxmlformats.org/officeDocument/2006/relationships" id="257" r:id="Rad07964a62ea4fc0"/>
-    <p:sldId xmlns:r="http://schemas.openxmlformats.org/officeDocument/2006/relationships" id="258" r:id="R598d8865e61d49ac"/>
-    <p:sldId xmlns:r="http://schemas.openxmlformats.org/officeDocument/2006/relationships" id="259" r:id="R3dc5a626c00c43c5"/>
-    <p:sldId xmlns:r="http://schemas.openxmlformats.org/officeDocument/2006/relationships" id="260" r:id="R2d0667cffa8944fc"/>
-    <p:sldId xmlns:r="http://schemas.openxmlformats.org/officeDocument/2006/relationships" id="261" r:id="Rc7b01f04705545c8"/>
-    <p:sldId xmlns:r="http://schemas.openxmlformats.org/officeDocument/2006/relationships" id="262" r:id="R484a9f7f64534a4b"/>
-    <p:sldId xmlns:r="http://schemas.openxmlformats.org/officeDocument/2006/relationships" id="263" r:id="Ra00048383c1544f2"/>
-    <p:sldId xmlns:r="http://schemas.openxmlformats.org/officeDocument/2006/relationships" id="264" r:id="Ra15fcace237049f3"/>
-    <p:sldId xmlns:r="http://schemas.openxmlformats.org/officeDocument/2006/relationships" id="265" r:id="R385a2abad5514d2f"/>
-    <p:sldId xmlns:r="http://schemas.openxmlformats.org/officeDocument/2006/relationships" id="266" r:id="R951c19ce46ef4a4f"/>
-    <p:sldId xmlns:r="http://schemas.openxmlformats.org/officeDocument/2006/relationships" id="267" r:id="Ra5f000aea2534e3a"/>
-    <p:sldId xmlns:r="http://schemas.openxmlformats.org/officeDocument/2006/relationships" id="268" r:id="Rb950c3ac41ae4615"/>
-    <p:sldId xmlns:r="http://schemas.openxmlformats.org/officeDocument/2006/relationships" id="269" r:id="Re819076286cd4919"/>
-    <p:sldId xmlns:r="http://schemas.openxmlformats.org/officeDocument/2006/relationships" id="270" r:id="Rf60d6fe5ec9f411b"/>
+    <p:sldId xmlns:r="http://schemas.openxmlformats.org/officeDocument/2006/relationships" id="256" r:id="R5c553f8840ac4464"/>
+    <p:sldId xmlns:r="http://schemas.openxmlformats.org/officeDocument/2006/relationships" id="257" r:id="R88f41a88fffd45eb"/>
+    <p:sldId xmlns:r="http://schemas.openxmlformats.org/officeDocument/2006/relationships" id="258" r:id="Rb4bc289dde034a31"/>
+    <p:sldId xmlns:r="http://schemas.openxmlformats.org/officeDocument/2006/relationships" id="259" r:id="R37c7722f471544dd"/>
+    <p:sldId xmlns:r="http://schemas.openxmlformats.org/officeDocument/2006/relationships" id="260" r:id="Rfd33d9263558415a"/>
+    <p:sldId xmlns:r="http://schemas.openxmlformats.org/officeDocument/2006/relationships" id="261" r:id="R94a4e74f55e944fb"/>
+    <p:sldId xmlns:r="http://schemas.openxmlformats.org/officeDocument/2006/relationships" id="262" r:id="R4e404ce9343445c7"/>
+    <p:sldId xmlns:r="http://schemas.openxmlformats.org/officeDocument/2006/relationships" id="263" r:id="R8e2b90e3926043d4"/>
+    <p:sldId xmlns:r="http://schemas.openxmlformats.org/officeDocument/2006/relationships" id="264" r:id="Rb057348f1d69430e"/>
+    <p:sldId xmlns:r="http://schemas.openxmlformats.org/officeDocument/2006/relationships" id="265" r:id="Rd4a935e9d03949fb"/>
+    <p:sldId xmlns:r="http://schemas.openxmlformats.org/officeDocument/2006/relationships" id="266" r:id="R6f60dbf387484073"/>
+    <p:sldId xmlns:r="http://schemas.openxmlformats.org/officeDocument/2006/relationships" id="267" r:id="Rc0554a44456443dd"/>
+    <p:sldId xmlns:r="http://schemas.openxmlformats.org/officeDocument/2006/relationships" id="268" r:id="R0546d10373fc49a4"/>
+    <p:sldId xmlns:r="http://schemas.openxmlformats.org/officeDocument/2006/relationships" id="269" r:id="R293190f440b3468c"/>
+    <p:sldId xmlns:r="http://schemas.openxmlformats.org/officeDocument/2006/relationships" id="270" r:id="R20dee9a4a3904a74"/>
   </p:sldIdLst>
   <p:sldSz cx="12192000" cy="6858000"/>
   <p:notesSz cx="6858000" cy="9144000"/>
@@ -1579,7 +1579,7 @@
   </p:cSld>
   <p:clrMap bg1="lt1" tx1="dk1" bg2="lt2" tx2="dk2" accent1="accent1" accent2="accent2" accent3="accent3" accent4="accent4" accent5="accent5" accent6="accent6" hlink="hlink" folHlink="folHlink"/>
   <p:sldLayoutIdLst>
-    <p:sldLayoutId xmlns:r="http://schemas.openxmlformats.org/officeDocument/2006/relationships" id="2147483649" r:id="Rd49a1574ff894178"/>
+    <p:sldLayoutId xmlns:r="http://schemas.openxmlformats.org/officeDocument/2006/relationships" id="2147483649" r:id="Rc2fc31cd400742e3"/>
   </p:sldLayoutIdLst>
   <p:txStyles>
     <p:titleStyle>
@@ -4083,26 +4083,26 @@
           </a:p>
         </p:txBody>
       </p:sp>
-      <p:pic xmlns:a="http://schemas.openxmlformats.org/drawingml/2006/main" xmlns:r="http://schemas.openxmlformats.org/officeDocument/2006/relationships">
+      <p:pic>
         <p:nvPicPr>
-          <p:cNvPr id="14" name="Picture 13" descr="sentiment-ml-mark.png"/>
+          <p:cNvPr id="26" name="Picture 13"/>
           <p:cNvPicPr>
-            <a:picLocks noChangeAspect="1"/>
+            <a:picLocks xmlns:a="http://schemas.openxmlformats.org/drawingml/2006/main" noChangeAspect="1"/>
           </p:cNvPicPr>
           <p:nvPr/>
         </p:nvPicPr>
         <p:blipFill>
-          <a:blip r:embed="rId5"/>
-          <a:stretch>
-            <a:fillRect/>
+          <a:blip xmlns:r="http://schemas.openxmlformats.org/officeDocument/2006/relationships" xmlns:a="http://schemas.openxmlformats.org/drawingml/2006/main" r:embed="Re7269e7ac488429a"/>
+          <a:stretch xmlns:a="http://schemas.openxmlformats.org/drawingml/2006/main">
+            <a:fillRect l="0" t="0" r="0" b="0"/>
           </a:stretch>
         </p:blipFill>
         <p:spPr>
-          <a:xfrm>
+          <a:xfrm xmlns:a="http://schemas.openxmlformats.org/drawingml/2006/main">
             <a:off x="8239125" y="1476375"/>
             <a:ext cx="3095625" cy="3095625"/>
           </a:xfrm>
-          <a:prstGeom prst="rect">
+          <a:prstGeom xmlns:a="http://schemas.openxmlformats.org/drawingml/2006/main" prst="rect">
             <a:avLst/>
           </a:prstGeom>
         </p:spPr>
@@ -4282,9 +4282,10 @@
             <a:prstDash val="solid"/>
           </a:ln>
         </p:spPr>
-        <p:txBody xmlns:a="http://schemas.openxmlformats.org/drawingml/2006/main">
-          <a:bodyPr/>
-          <a:p/>
+        <p:txBody>
+          <a:bodyPr xmlns:a="http://schemas.openxmlformats.org/drawingml/2006/main"/>
+          <a:lstStyle xmlns:a="http://schemas.openxmlformats.org/drawingml/2006/main"/>
+          <a:p xmlns:a="http://schemas.openxmlformats.org/drawingml/2006/main"/>
         </p:txBody>
       </p:sp>
       <p:sp>
@@ -4781,9 +4782,10 @@
             <a:prstDash val="solid"/>
           </a:ln>
         </p:spPr>
-        <p:txBody xmlns:a="http://schemas.openxmlformats.org/drawingml/2006/main">
-          <a:bodyPr/>
-          <a:p/>
+        <p:txBody>
+          <a:bodyPr xmlns:a="http://schemas.openxmlformats.org/drawingml/2006/main"/>
+          <a:lstStyle xmlns:a="http://schemas.openxmlformats.org/drawingml/2006/main"/>
+          <a:p xmlns:a="http://schemas.openxmlformats.org/drawingml/2006/main"/>
         </p:txBody>
       </p:sp>
       <p:sp>
@@ -4990,9 +4992,10 @@
             <a:prstDash val="solid"/>
           </a:ln>
         </p:spPr>
-        <p:txBody xmlns:a="http://schemas.openxmlformats.org/drawingml/2006/main">
-          <a:bodyPr/>
-          <a:p/>
+        <p:txBody>
+          <a:bodyPr xmlns:a="http://schemas.openxmlformats.org/drawingml/2006/main"/>
+          <a:lstStyle xmlns:a="http://schemas.openxmlformats.org/drawingml/2006/main"/>
+          <a:p xmlns:a="http://schemas.openxmlformats.org/drawingml/2006/main"/>
         </p:txBody>
       </p:sp>
       <p:sp>
@@ -5473,7 +5476,7 @@
         </p:xfrm>
         <a:graphic xmlns:a="http://schemas.openxmlformats.org/drawingml/2006/main">
           <a:graphicData uri="http://schemas.openxmlformats.org/drawingml/2006/chart">
-            <c:chart xmlns:r="http://schemas.openxmlformats.org/officeDocument/2006/relationships" xmlns:c="http://schemas.openxmlformats.org/drawingml/2006/chart" r:id="R0f0d06d4599148b7"/>
+            <c:chart xmlns:r="http://schemas.openxmlformats.org/officeDocument/2006/relationships" xmlns:c="http://schemas.openxmlformats.org/drawingml/2006/chart" r:id="Rf190e7675f194289"/>
           </a:graphicData>
         </a:graphic>
       </p:graphicFrame>
@@ -6157,9 +6160,10 @@
             <a:prstDash val="solid"/>
           </a:ln>
         </p:spPr>
-        <p:txBody xmlns:a="http://schemas.openxmlformats.org/drawingml/2006/main">
-          <a:bodyPr/>
-          <a:p/>
+        <p:txBody>
+          <a:bodyPr xmlns:a="http://schemas.openxmlformats.org/drawingml/2006/main"/>
+          <a:lstStyle xmlns:a="http://schemas.openxmlformats.org/drawingml/2006/main"/>
+          <a:p xmlns:a="http://schemas.openxmlformats.org/drawingml/2006/main"/>
         </p:txBody>
       </p:sp>
       <p:sp>
@@ -6222,7 +6226,7 @@
       </p:sp>
       <p:graphicFrame>
         <p:nvGraphicFramePr>
-          <p:cNvPr id="19" name="Chart"/>
+          <p:cNvPr id="26" name="Chart"/>
           <p:cNvGraphicFramePr/>
           <p:nvPr/>
         </p:nvGraphicFramePr>
@@ -6232,7 +6236,7 @@
         </p:xfrm>
         <a:graphic xmlns:a="http://schemas.openxmlformats.org/drawingml/2006/main">
           <a:graphicData uri="http://schemas.openxmlformats.org/drawingml/2006/chart">
-            <c:chart xmlns:r="http://schemas.openxmlformats.org/officeDocument/2006/relationships" xmlns:c="http://schemas.openxmlformats.org/drawingml/2006/chart" r:id="Rc85f94e2a97d4378"/>
+            <c:chart xmlns:r="http://schemas.openxmlformats.org/officeDocument/2006/relationships" xmlns:c="http://schemas.openxmlformats.org/drawingml/2006/chart" r:id="R892cce6c92ac4b84"/>
           </a:graphicData>
         </a:graphic>
       </p:graphicFrame>
@@ -6642,56 +6646,68 @@
           </a:p>
         </p:txBody>
       </p:sp>
-      <p:sp xmlns:a="http://schemas.openxmlformats.org/drawingml/2006/main">
-        <p:nvSpPr>
-          <p:cNvPr id="20" name="Rounded Rectangle 19"/>
-          <p:cNvSpPr/>
-          <p:nvPr/>
-        </p:nvSpPr>
-        <p:spPr>
-          <a:xfrm>
+      <p:sp>
+        <p:nvSpPr>
+          <p:cNvPr id="20" name="Rounded Rectangle 19">
+            <a:extLst xmlns:a="http://schemas.openxmlformats.org/drawingml/2006/main">
+              <a:ext uri="{FF2B5EF4-FFF2-40B4-BE49-F238E27FC236}">
+                <a16:creationId xmlns:a16="http://schemas.microsoft.com/office/drawing/2014/main" id="{303C1C47-2DBC-42DA-AD3E-F3E0ED78845D}"/>
+              </a:ext>
+            </a:extLst>
+          </p:cNvPr>
+          <p:cNvSpPr>
+            <a:spLocks xmlns:a="http://schemas.openxmlformats.org/drawingml/2006/main" noGrp="1"/>
+          </p:cNvSpPr>
+          <p:nvPr/>
+        </p:nvSpPr>
+        <p:spPr>
+          <a:xfrm xmlns:a="http://schemas.openxmlformats.org/drawingml/2006/main">
             <a:off x="612648" y="5870448"/>
             <a:ext cx="10424160" cy="475488"/>
           </a:xfrm>
-          <a:prstGeom prst="roundRect">
+          <a:prstGeom xmlns:a="http://schemas.openxmlformats.org/drawingml/2006/main" prst="roundRect">
             <a:avLst>
               <a:gd name="adj" fmla="val 15000"/>
             </a:avLst>
           </a:prstGeom>
-          <a:solidFill>
+          <a:solidFill xmlns:a="http://schemas.openxmlformats.org/drawingml/2006/main">
             <a:srgbClr val="141B26"/>
           </a:solidFill>
-          <a:ln w="12700">
+          <a:ln xmlns:a="http://schemas.openxmlformats.org/drawingml/2006/main" w="12700">
             <a:solidFill>
               <a:srgbClr val="7AA7FF"/>
             </a:solidFill>
           </a:ln>
         </p:spPr>
         <p:style>
-          <a:lnRef idx="1">
+          <a:lnRef xmlns:a="http://schemas.openxmlformats.org/drawingml/2006/main" idx="1">
             <a:schemeClr val="accent1"/>
           </a:lnRef>
-          <a:fillRef idx="3">
+          <a:fillRef xmlns:a="http://schemas.openxmlformats.org/drawingml/2006/main" idx="3">
             <a:schemeClr val="accent1"/>
           </a:fillRef>
-          <a:effectRef idx="2">
+          <a:effectRef xmlns:a="http://schemas.openxmlformats.org/drawingml/2006/main" idx="2">
             <a:schemeClr val="accent1"/>
           </a:effectRef>
-          <a:fontRef idx="minor">
+          <a:fontRef xmlns:a="http://schemas.openxmlformats.org/drawingml/2006/main" idx="minor">
             <a:schemeClr val="lt1"/>
           </a:fontRef>
         </p:style>
         <p:txBody>
-          <a:bodyPr rtlCol="0" anchor="ctr" lIns="182880" rIns="182880" tIns="73152" bIns="73152"/>
-          <a:lstStyle/>
-          <a:p>
-            <a:pPr algn="l"/>
+          <a:bodyPr xmlns:a="http://schemas.openxmlformats.org/drawingml/2006/main" lIns="182880" tIns="73152" rIns="182880" bIns="73152" anchor="ctr"/>
+          <a:lstStyle xmlns:a="http://schemas.openxmlformats.org/drawingml/2006/main"/>
+          <a:p xmlns:a="http://schemas.openxmlformats.org/drawingml/2006/main">
+            <a:pPr algn="l">
+              <a:buNone/>
+            </a:pPr>
             <a:r>
               <a:rPr sz="1200" b="1">
                 <a:solidFill>
                   <a:srgbClr val="7AA7FF"/>
                 </a:solidFill>
                 <a:latin typeface="Helvetica Neue"/>
+                <a:ea typeface="Helvetica Neue"/>
+                <a:cs typeface="Helvetica Neue"/>
               </a:rPr>
               <a:t>💬 Review minh họa: </a:t>
             </a:r>
@@ -6701,6 +6717,8 @@
                   <a:srgbClr val="F1F5F9"/>
                 </a:solidFill>
                 <a:latin typeface="Helvetica Neue"/>
+                <a:ea typeface="Helvetica Neue"/>
+                <a:cs typeface="Helvetica Neue"/>
               </a:rPr>
               <a:t>"Lương thấp, quản lý thiếu minh bạch và thường xuyên phải OT không lương."</a:t>
             </a:r>
@@ -6710,6 +6728,8 @@
                   <a:srgbClr val="9EABBA"/>
                 </a:solidFill>
                 <a:latin typeface="Helvetica Neue"/>
+                <a:ea typeface="Helvetica Neue"/>
+                <a:cs typeface="Helvetica Neue"/>
               </a:rPr>
               <a:t>  →  Mô hình nhận diện: </a:t>
             </a:r>
@@ -6719,6 +6739,8 @@
                   <a:srgbClr val="FF6677"/>
                 </a:solidFill>
                 <a:latin typeface="Helvetica Neue"/>
+                <a:ea typeface="Helvetica Neue"/>
+                <a:cs typeface="Helvetica Neue"/>
               </a:rPr>
               <a:t>Tiêu cực (99,0%)</a:t>
             </a:r>
@@ -8247,9 +8269,10 @@
             <a:prstDash val="solid"/>
           </a:ln>
         </p:spPr>
-        <p:txBody xmlns:a="http://schemas.openxmlformats.org/drawingml/2006/main">
-          <a:bodyPr/>
-          <a:p/>
+        <p:txBody>
+          <a:bodyPr xmlns:a="http://schemas.openxmlformats.org/drawingml/2006/main"/>
+          <a:lstStyle xmlns:a="http://schemas.openxmlformats.org/drawingml/2006/main"/>
+          <a:p xmlns:a="http://schemas.openxmlformats.org/drawingml/2006/main"/>
         </p:txBody>
       </p:sp>
       <p:sp>
@@ -8400,9 +8423,10 @@
             <a:prstDash val="solid"/>
           </a:ln>
         </p:spPr>
-        <p:txBody xmlns:a="http://schemas.openxmlformats.org/drawingml/2006/main">
-          <a:bodyPr/>
-          <a:p/>
+        <p:txBody>
+          <a:bodyPr xmlns:a="http://schemas.openxmlformats.org/drawingml/2006/main"/>
+          <a:lstStyle xmlns:a="http://schemas.openxmlformats.org/drawingml/2006/main"/>
+          <a:p xmlns:a="http://schemas.openxmlformats.org/drawingml/2006/main"/>
         </p:txBody>
       </p:sp>
       <p:sp>
@@ -8553,9 +8577,10 @@
             <a:prstDash val="solid"/>
           </a:ln>
         </p:spPr>
-        <p:txBody xmlns:a="http://schemas.openxmlformats.org/drawingml/2006/main">
-          <a:bodyPr/>
-          <a:p/>
+        <p:txBody>
+          <a:bodyPr xmlns:a="http://schemas.openxmlformats.org/drawingml/2006/main"/>
+          <a:lstStyle xmlns:a="http://schemas.openxmlformats.org/drawingml/2006/main"/>
+          <a:p xmlns:a="http://schemas.openxmlformats.org/drawingml/2006/main"/>
         </p:txBody>
       </p:sp>
       <p:sp>
@@ -8706,9 +8731,10 @@
             <a:prstDash val="solid"/>
           </a:ln>
         </p:spPr>
-        <p:txBody xmlns:a="http://schemas.openxmlformats.org/drawingml/2006/main">
-          <a:bodyPr/>
-          <a:p/>
+        <p:txBody>
+          <a:bodyPr xmlns:a="http://schemas.openxmlformats.org/drawingml/2006/main"/>
+          <a:lstStyle xmlns:a="http://schemas.openxmlformats.org/drawingml/2006/main"/>
+          <a:p xmlns:a="http://schemas.openxmlformats.org/drawingml/2006/main"/>
         </p:txBody>
       </p:sp>
       <p:sp>
@@ -8857,9 +8883,10 @@
             <a:prstDash val="solid"/>
           </a:ln>
         </p:spPr>
-        <p:txBody xmlns:a="http://schemas.openxmlformats.org/drawingml/2006/main">
-          <a:bodyPr/>
-          <a:p/>
+        <p:txBody>
+          <a:bodyPr xmlns:a="http://schemas.openxmlformats.org/drawingml/2006/main"/>
+          <a:lstStyle xmlns:a="http://schemas.openxmlformats.org/drawingml/2006/main"/>
+          <a:p xmlns:a="http://schemas.openxmlformats.org/drawingml/2006/main"/>
         </p:txBody>
       </p:sp>
       <p:sp>
@@ -8952,9 +8979,10 @@
             <a:prstDash val="solid"/>
           </a:ln>
         </p:spPr>
-        <p:txBody xmlns:a="http://schemas.openxmlformats.org/drawingml/2006/main">
-          <a:bodyPr/>
-          <a:p/>
+        <p:txBody>
+          <a:bodyPr xmlns:a="http://schemas.openxmlformats.org/drawingml/2006/main"/>
+          <a:lstStyle xmlns:a="http://schemas.openxmlformats.org/drawingml/2006/main"/>
+          <a:p xmlns:a="http://schemas.openxmlformats.org/drawingml/2006/main"/>
         </p:txBody>
       </p:sp>
       <p:sp>
@@ -9105,9 +9133,10 @@
             <a:prstDash val="solid"/>
           </a:ln>
         </p:spPr>
-        <p:txBody xmlns:a="http://schemas.openxmlformats.org/drawingml/2006/main">
-          <a:bodyPr/>
-          <a:p/>
+        <p:txBody>
+          <a:bodyPr xmlns:a="http://schemas.openxmlformats.org/drawingml/2006/main"/>
+          <a:lstStyle xmlns:a="http://schemas.openxmlformats.org/drawingml/2006/main"/>
+          <a:p xmlns:a="http://schemas.openxmlformats.org/drawingml/2006/main"/>
         </p:txBody>
       </p:sp>
       <p:sp>
@@ -9258,9 +9287,10 @@
             <a:prstDash val="solid"/>
           </a:ln>
         </p:spPr>
-        <p:txBody xmlns:a="http://schemas.openxmlformats.org/drawingml/2006/main">
-          <a:bodyPr/>
-          <a:p/>
+        <p:txBody>
+          <a:bodyPr xmlns:a="http://schemas.openxmlformats.org/drawingml/2006/main"/>
+          <a:lstStyle xmlns:a="http://schemas.openxmlformats.org/drawingml/2006/main"/>
+          <a:p xmlns:a="http://schemas.openxmlformats.org/drawingml/2006/main"/>
         </p:txBody>
       </p:sp>
       <p:sp>
@@ -9375,64 +9405,6 @@
                 <a:cs typeface="Helvetica Neue"/>
               </a:rPr>
               <a:t>Đối sánh với PhoBERT hoặc ViSoBERT khi có tài nguyên.</a:t>
-            </a:r>
-          </a:p>
-        </p:txBody>
-      </p:sp>
-      <p:sp>
-        <p:nvSpPr>
-          <p:cNvPr id="26" name="">
-            <a:extLst xmlns:a="http://schemas.openxmlformats.org/drawingml/2006/main">
-              <a:ext uri="{FF2B5EF4-FFF2-40B4-BE49-F238E27FC236}">
-                <a16:creationId xmlns:a16="http://schemas.microsoft.com/office/drawing/2014/main" id="{FBF425F4-BB3B-4DF9-A324-02D8E9A703CF}"/>
-              </a:ext>
-            </a:extLst>
-          </p:cNvPr>
-          <p:cNvSpPr>
-            <a:spLocks xmlns:a="http://schemas.openxmlformats.org/drawingml/2006/main" noGrp="1"/>
-          </p:cNvSpPr>
-          <p:nvPr/>
-        </p:nvSpPr>
-        <p:spPr>
-          <a:xfrm xmlns:a="http://schemas.openxmlformats.org/drawingml/2006/main">
-            <a:off x="609600" y="5905500"/>
-            <a:ext cx="10287000" cy="419100"/>
-          </a:xfrm>
-          <a:prstGeom xmlns:a="http://schemas.openxmlformats.org/drawingml/2006/main" prst="rect">
-            <a:avLst/>
-          </a:prstGeom>
-          <a:noFill xmlns:a="http://schemas.openxmlformats.org/drawingml/2006/main"/>
-          <a:ln xmlns:a="http://schemas.openxmlformats.org/drawingml/2006/main" w="0">
-            <a:noFill/>
-          </a:ln>
-        </p:spPr>
-        <p:txBody>
-          <a:bodyPr xmlns:a="http://schemas.openxmlformats.org/drawingml/2006/main" anchor="t">
-            <a:normAutofit fontScale="100000"/>
-          </a:bodyPr>
-          <a:lstStyle xmlns:a="http://schemas.openxmlformats.org/drawingml/2006/main"/>
-          <a:p xmlns:a="http://schemas.openxmlformats.org/drawingml/2006/main">
-            <a:pPr algn="l">
-              <a:buNone/>
-              <a:defRPr sz="2100" b="1">
-                <a:solidFill>
-                  <a:srgbClr val="45D9A0"/>
-                </a:solidFill>
-                <a:latin typeface="Helvetica Neue"/>
-                <a:ea typeface="Helvetica Neue"/>
-                <a:cs typeface="Helvetica Neue"/>
-              </a:defRPr>
-            </a:pPr>
-            <a:r>
-              <a:rPr sz="2100" b="1">
-                <a:solidFill>
-                  <a:srgbClr val="45D9A0"/>
-                </a:solidFill>
-                <a:latin typeface="Helvetica Neue"/>
-                <a:ea typeface="Helvetica Neue"/>
-                <a:cs typeface="Helvetica Neue"/>
-              </a:rPr>
-              <a:t>Kết thúc nội dung chính. Tiếp theo: live demo.</a:t>
             </a:r>
           </a:p>
         </p:txBody>
@@ -9612,9 +9584,10 @@
             <a:prstDash val="solid"/>
           </a:ln>
         </p:spPr>
-        <p:txBody xmlns:a="http://schemas.openxmlformats.org/drawingml/2006/main">
-          <a:bodyPr/>
-          <a:p/>
+        <p:txBody>
+          <a:bodyPr xmlns:a="http://schemas.openxmlformats.org/drawingml/2006/main"/>
+          <a:lstStyle xmlns:a="http://schemas.openxmlformats.org/drawingml/2006/main"/>
+          <a:p xmlns:a="http://schemas.openxmlformats.org/drawingml/2006/main"/>
         </p:txBody>
       </p:sp>
       <p:sp>
@@ -9879,9 +9852,10 @@
             <a:prstDash val="solid"/>
           </a:ln>
         </p:spPr>
-        <p:txBody xmlns:a="http://schemas.openxmlformats.org/drawingml/2006/main">
-          <a:bodyPr/>
-          <a:p/>
+        <p:txBody>
+          <a:bodyPr xmlns:a="http://schemas.openxmlformats.org/drawingml/2006/main"/>
+          <a:lstStyle xmlns:a="http://schemas.openxmlformats.org/drawingml/2006/main"/>
+          <a:p xmlns:a="http://schemas.openxmlformats.org/drawingml/2006/main"/>
         </p:txBody>
       </p:sp>
       <p:sp>
@@ -10884,7 +10858,7 @@
         </p:xfrm>
         <a:graphic xmlns:a="http://schemas.openxmlformats.org/drawingml/2006/main">
           <a:graphicData uri="http://schemas.openxmlformats.org/drawingml/2006/chart">
-            <c:chart xmlns:r="http://schemas.openxmlformats.org/officeDocument/2006/relationships" xmlns:c="http://schemas.openxmlformats.org/drawingml/2006/chart" r:id="Rd715ca4579904bc8"/>
+            <c:chart xmlns:r="http://schemas.openxmlformats.org/officeDocument/2006/relationships" xmlns:c="http://schemas.openxmlformats.org/drawingml/2006/chart" r:id="R6d33cb1b258045f1"/>
           </a:graphicData>
         </a:graphic>
       </p:graphicFrame>
@@ -12784,7 +12758,7 @@
       </p:sp>
       <p:cxnSp>
         <p:nvCxnSpPr>
-          <p:cNvPr id="114" name=""/>
+          <p:cNvPr id="142" name=""/>
           <p:cNvCxnSpPr>
             <a:stCxn xmlns:a="http://schemas.openxmlformats.org/drawingml/2006/main" id="8" idx="3"/>
             <a:endCxn xmlns:a="http://schemas.openxmlformats.org/drawingml/2006/main" id="12" idx="1"/>
@@ -12810,7 +12784,7 @@
       </p:cxnSp>
       <p:cxnSp>
         <p:nvCxnSpPr>
-          <p:cNvPr id="115" name=""/>
+          <p:cNvPr id="143" name=""/>
           <p:cNvCxnSpPr>
             <a:stCxn xmlns:a="http://schemas.openxmlformats.org/drawingml/2006/main" id="12" idx="3"/>
             <a:endCxn xmlns:a="http://schemas.openxmlformats.org/drawingml/2006/main" id="16" idx="1"/>
@@ -12836,7 +12810,7 @@
       </p:cxnSp>
       <p:cxnSp>
         <p:nvCxnSpPr>
-          <p:cNvPr id="116" name=""/>
+          <p:cNvPr id="144" name=""/>
           <p:cNvCxnSpPr>
             <a:stCxn xmlns:a="http://schemas.openxmlformats.org/drawingml/2006/main" id="16" idx="3"/>
             <a:endCxn xmlns:a="http://schemas.openxmlformats.org/drawingml/2006/main" id="20" idx="1"/>
@@ -12862,7 +12836,7 @@
       </p:cxnSp>
       <p:cxnSp>
         <p:nvCxnSpPr>
-          <p:cNvPr id="117" name=""/>
+          <p:cNvPr id="145" name=""/>
           <p:cNvCxnSpPr>
             <a:stCxn xmlns:a="http://schemas.openxmlformats.org/drawingml/2006/main" id="20" idx="3"/>
             <a:endCxn xmlns:a="http://schemas.openxmlformats.org/drawingml/2006/main" id="24" idx="1"/>
@@ -14640,7 +14614,7 @@
           <p:nvPr/>
         </p:nvPicPr>
         <p:blipFill>
-          <a:blip xmlns:r="http://schemas.openxmlformats.org/officeDocument/2006/relationships" xmlns:a="http://schemas.openxmlformats.org/drawingml/2006/main" r:embed="Rf3f4e884f7034a0a"/>
+          <a:blip xmlns:r="http://schemas.openxmlformats.org/officeDocument/2006/relationships" xmlns:a="http://schemas.openxmlformats.org/drawingml/2006/main" r:embed="R1481708e5bd44e57"/>
           <a:stretch xmlns:a="http://schemas.openxmlformats.org/drawingml/2006/main"/>
         </p:blipFill>
         <p:spPr>
@@ -15305,7 +15279,7 @@
         </p:xfrm>
         <a:graphic xmlns:a="http://schemas.openxmlformats.org/drawingml/2006/main">
           <a:graphicData uri="http://schemas.openxmlformats.org/drawingml/2006/chart">
-            <c:chart xmlns:r="http://schemas.openxmlformats.org/officeDocument/2006/relationships" xmlns:c="http://schemas.openxmlformats.org/drawingml/2006/chart" r:id="Rb17d24a0874d4fb8"/>
+            <c:chart xmlns:r="http://schemas.openxmlformats.org/officeDocument/2006/relationships" xmlns:c="http://schemas.openxmlformats.org/drawingml/2006/chart" r:id="Rb7ed362d7b48419c"/>
           </a:graphicData>
         </a:graphic>
       </p:graphicFrame>
@@ -17528,7 +17502,7 @@
       </p:sp>
       <p:cxnSp>
         <p:nvCxnSpPr>
-          <p:cNvPr id="123" name=""/>
+          <p:cNvPr id="154" name=""/>
           <p:cNvCxnSpPr>
             <a:stCxn xmlns:a="http://schemas.openxmlformats.org/drawingml/2006/main" id="17" idx="3"/>
             <a:endCxn xmlns:a="http://schemas.openxmlformats.org/drawingml/2006/main" id="20" idx="1"/>
@@ -17554,7 +17528,7 @@
       </p:cxnSp>
       <p:cxnSp>
         <p:nvCxnSpPr>
-          <p:cNvPr id="124" name=""/>
+          <p:cNvPr id="155" name=""/>
           <p:cNvCxnSpPr>
             <a:stCxn xmlns:a="http://schemas.openxmlformats.org/drawingml/2006/main" id="20" idx="3"/>
             <a:endCxn xmlns:a="http://schemas.openxmlformats.org/drawingml/2006/main" id="23" idx="1"/>
@@ -17580,7 +17554,7 @@
       </p:cxnSp>
       <p:cxnSp>
         <p:nvCxnSpPr>
-          <p:cNvPr id="125" name=""/>
+          <p:cNvPr id="156" name=""/>
           <p:cNvCxnSpPr>
             <a:stCxn xmlns:a="http://schemas.openxmlformats.org/drawingml/2006/main" id="23" idx="3"/>
             <a:endCxn xmlns:a="http://schemas.openxmlformats.org/drawingml/2006/main" id="26" idx="1"/>
@@ -17837,9 +17811,10 @@
             <a:prstDash val="solid"/>
           </a:ln>
         </p:spPr>
-        <p:txBody xmlns:a="http://schemas.openxmlformats.org/drawingml/2006/main">
-          <a:bodyPr/>
-          <a:p/>
+        <p:txBody>
+          <a:bodyPr xmlns:a="http://schemas.openxmlformats.org/drawingml/2006/main"/>
+          <a:lstStyle xmlns:a="http://schemas.openxmlformats.org/drawingml/2006/main"/>
+          <a:p xmlns:a="http://schemas.openxmlformats.org/drawingml/2006/main"/>
         </p:txBody>
       </p:sp>
       <p:sp>
@@ -17912,7 +17887,7 @@
         </p:xfrm>
         <a:graphic xmlns:a="http://schemas.openxmlformats.org/drawingml/2006/main">
           <a:graphicData uri="http://schemas.openxmlformats.org/drawingml/2006/chart">
-            <c:chart xmlns:r="http://schemas.openxmlformats.org/officeDocument/2006/relationships" xmlns:c="http://schemas.openxmlformats.org/drawingml/2006/chart" r:id="Re88c139d27314149"/>
+            <c:chart xmlns:r="http://schemas.openxmlformats.org/officeDocument/2006/relationships" xmlns:c="http://schemas.openxmlformats.org/drawingml/2006/chart" r:id="R8dc8b11500ca4baf"/>
           </a:graphicData>
         </a:graphic>
       </p:graphicFrame>
@@ -18180,9 +18155,10 @@
             <a:prstDash val="solid"/>
           </a:ln>
         </p:spPr>
-        <p:txBody xmlns:a="http://schemas.openxmlformats.org/drawingml/2006/main">
-          <a:bodyPr/>
-          <a:p/>
+        <p:txBody>
+          <a:bodyPr xmlns:a="http://schemas.openxmlformats.org/drawingml/2006/main"/>
+          <a:lstStyle xmlns:a="http://schemas.openxmlformats.org/drawingml/2006/main"/>
+          <a:p xmlns:a="http://schemas.openxmlformats.org/drawingml/2006/main"/>
         </p:txBody>
       </p:sp>
       <p:sp>
@@ -18333,9 +18309,10 @@
             <a:prstDash val="solid"/>
           </a:ln>
         </p:spPr>
-        <p:txBody xmlns:a="http://schemas.openxmlformats.org/drawingml/2006/main">
-          <a:bodyPr/>
-          <a:p/>
+        <p:txBody>
+          <a:bodyPr xmlns:a="http://schemas.openxmlformats.org/drawingml/2006/main"/>
+          <a:lstStyle xmlns:a="http://schemas.openxmlformats.org/drawingml/2006/main"/>
+          <a:p xmlns:a="http://schemas.openxmlformats.org/drawingml/2006/main"/>
         </p:txBody>
       </p:sp>
       <p:sp>
@@ -18486,9 +18463,10 @@
             <a:prstDash val="solid"/>
           </a:ln>
         </p:spPr>
-        <p:txBody xmlns:a="http://schemas.openxmlformats.org/drawingml/2006/main">
-          <a:bodyPr/>
-          <a:p/>
+        <p:txBody>
+          <a:bodyPr xmlns:a="http://schemas.openxmlformats.org/drawingml/2006/main"/>
+          <a:lstStyle xmlns:a="http://schemas.openxmlformats.org/drawingml/2006/main"/>
+          <a:p xmlns:a="http://schemas.openxmlformats.org/drawingml/2006/main"/>
         </p:txBody>
       </p:sp>
       <p:sp>
@@ -18782,9 +18760,10 @@
             <a:prstDash val="solid"/>
           </a:ln>
         </p:spPr>
-        <p:txBody xmlns:a="http://schemas.openxmlformats.org/drawingml/2006/main">
-          <a:bodyPr/>
-          <a:p/>
+        <p:txBody>
+          <a:bodyPr xmlns:a="http://schemas.openxmlformats.org/drawingml/2006/main"/>
+          <a:lstStyle xmlns:a="http://schemas.openxmlformats.org/drawingml/2006/main"/>
+          <a:p xmlns:a="http://schemas.openxmlformats.org/drawingml/2006/main"/>
         </p:txBody>
       </p:sp>
       <p:sp>
@@ -19308,13 +19287,17 @@
             </a:r>
           </a:p>
           <a:p xmlns:a="http://schemas.openxmlformats.org/drawingml/2006/main">
-            <a:pPr algn="l"/>
+            <a:pPr algn="l">
+              <a:buNone/>
+            </a:pPr>
             <a:r>
               <a:rPr sz="1100" b="1">
                 <a:solidFill>
                   <a:srgbClr val="50E3A4"/>
                 </a:solidFill>
                 <a:latin typeface="Helvetica Neue"/>
+                <a:ea typeface="Helvetica Neue"/>
+                <a:cs typeface="Helvetica Neue"/>
               </a:rPr>
               <a:t>(Bản cũ: 442 → Giảm 10 mẫu)</a:t>
             </a:r>
@@ -19323,7 +19306,7 @@
       </p:sp>
       <p:graphicFrame>
         <p:nvGraphicFramePr>
-          <p:cNvPr id="32" name=""/>
+          <p:cNvPr id="49" name=""/>
           <p:cNvGraphicFramePr/>
           <p:nvPr/>
         </p:nvGraphicFramePr>
@@ -19469,10 +19452,14 @@
                     <a:bodyPr/>
                     <a:lstStyle/>
                     <a:p>
-                      <a:pPr algn="ctr"/>
+                      <a:pPr algn="ctr">
+                        <a:buNone/>
+                      </a:pPr>
                       <a:r>
                         <a:rPr sz="1300" b="1">
                           <a:latin typeface="Helvetica Neue"/>
+                          <a:ea typeface="Helvetica Neue"/>
+                          <a:cs typeface="Helvetica Neue"/>
                         </a:rPr>
                         <a:t>52 (45,6%)</a:t>
                       </a:r>
@@ -19587,10 +19574,14 @@
                     <a:bodyPr/>
                     <a:lstStyle/>
                     <a:p>
-                      <a:pPr algn="ctr"/>
+                      <a:pPr algn="ctr">
+                        <a:buNone/>
+                      </a:pPr>
                       <a:r>
                         <a:rPr sz="1300" b="1">
                           <a:latin typeface="Helvetica Neue"/>
+                          <a:ea typeface="Helvetica Neue"/>
+                          <a:cs typeface="Helvetica Neue"/>
                         </a:rPr>
                         <a:t>168 (51,2%)</a:t>
                       </a:r>
@@ -19705,10 +19696,14 @@
                     <a:bodyPr/>
                     <a:lstStyle/>
                     <a:p>
-                      <a:pPr algn="ctr"/>
+                      <a:pPr algn="ctr">
+                        <a:buNone/>
+                      </a:pPr>
                       <a:r>
                         <a:rPr sz="1300" b="1">
                           <a:latin typeface="Helvetica Neue"/>
+                          <a:ea typeface="Helvetica Neue"/>
+                          <a:cs typeface="Helvetica Neue"/>
                         </a:rPr>
                         <a:t>1.031 (83,1%)</a:t>
                       </a:r>
@@ -19727,7 +19722,7 @@
       </p:graphicFrame>
       <p:graphicFrame>
         <p:nvGraphicFramePr>
-          <p:cNvPr id="33" name="Chart"/>
+          <p:cNvPr id="50" name="Chart"/>
           <p:cNvGraphicFramePr/>
           <p:nvPr/>
         </p:nvGraphicFramePr>
@@ -19737,7 +19732,7 @@
         </p:xfrm>
         <a:graphic xmlns:a="http://schemas.openxmlformats.org/drawingml/2006/main">
           <a:graphicData uri="http://schemas.openxmlformats.org/drawingml/2006/chart">
-            <c:chart xmlns:r="http://schemas.openxmlformats.org/officeDocument/2006/relationships" xmlns:c="http://schemas.openxmlformats.org/drawingml/2006/chart" r:id="Rfdddb44e8e944fdc"/>
+            <c:chart xmlns:r="http://schemas.openxmlformats.org/officeDocument/2006/relationships" xmlns:c="http://schemas.openxmlformats.org/drawingml/2006/chart" r:id="R2795b788fb2e4081"/>
           </a:graphicData>
         </a:graphic>
       </p:graphicFrame>
@@ -19857,56 +19852,68 @@
           </a:p>
         </p:txBody>
       </p:sp>
-      <p:sp xmlns:a="http://schemas.openxmlformats.org/drawingml/2006/main">
-        <p:nvSpPr>
-          <p:cNvPr id="34" name="Rounded Rectangle 33"/>
-          <p:cNvSpPr/>
-          <p:nvPr/>
-        </p:nvSpPr>
-        <p:spPr>
-          <a:xfrm>
+      <p:sp>
+        <p:nvSpPr>
+          <p:cNvPr id="34" name="Rounded Rectangle 33">
+            <a:extLst xmlns:a="http://schemas.openxmlformats.org/drawingml/2006/main">
+              <a:ext uri="{FF2B5EF4-FFF2-40B4-BE49-F238E27FC236}">
+                <a16:creationId xmlns:a16="http://schemas.microsoft.com/office/drawing/2014/main" id="{9D2DFA3B-6B5F-4A31-ABCD-E8D09A5BD22C}"/>
+              </a:ext>
+            </a:extLst>
+          </p:cNvPr>
+          <p:cNvSpPr>
+            <a:spLocks xmlns:a="http://schemas.openxmlformats.org/drawingml/2006/main" noGrp="1"/>
+          </p:cNvSpPr>
+          <p:nvPr/>
+        </p:nvSpPr>
+        <p:spPr>
+          <a:xfrm xmlns:a="http://schemas.openxmlformats.org/drawingml/2006/main">
             <a:off x="7242048" y="5321808"/>
             <a:ext cx="4005072" cy="347472"/>
           </a:xfrm>
-          <a:prstGeom prst="roundRect">
+          <a:prstGeom xmlns:a="http://schemas.openxmlformats.org/drawingml/2006/main" prst="roundRect">
             <a:avLst>
               <a:gd name="adj" fmla="val 20000"/>
             </a:avLst>
           </a:prstGeom>
-          <a:solidFill>
+          <a:solidFill xmlns:a="http://schemas.openxmlformats.org/drawingml/2006/main">
             <a:srgbClr val="1B2433"/>
           </a:solidFill>
-          <a:ln w="12700">
+          <a:ln xmlns:a="http://schemas.openxmlformats.org/drawingml/2006/main" w="12700">
             <a:solidFill>
               <a:srgbClr val="FF6677"/>
             </a:solidFill>
           </a:ln>
         </p:spPr>
         <p:style>
-          <a:lnRef idx="1">
+          <a:lnRef xmlns:a="http://schemas.openxmlformats.org/drawingml/2006/main" idx="1">
             <a:schemeClr val="accent1"/>
           </a:lnRef>
-          <a:fillRef idx="3">
+          <a:fillRef xmlns:a="http://schemas.openxmlformats.org/drawingml/2006/main" idx="3">
             <a:schemeClr val="accent1"/>
           </a:fillRef>
-          <a:effectRef idx="2">
+          <a:effectRef xmlns:a="http://schemas.openxmlformats.org/drawingml/2006/main" idx="2">
             <a:schemeClr val="accent1"/>
           </a:effectRef>
-          <a:fontRef idx="minor">
+          <a:fontRef xmlns:a="http://schemas.openxmlformats.org/drawingml/2006/main" idx="minor">
             <a:schemeClr val="lt1"/>
           </a:fontRef>
         </p:style>
         <p:txBody>
-          <a:bodyPr rtlCol="0" anchor="ctr" lIns="0" rIns="0" tIns="0" bIns="0"/>
-          <a:lstStyle/>
-          <a:p>
-            <a:pPr algn="ctr"/>
+          <a:bodyPr xmlns:a="http://schemas.openxmlformats.org/drawingml/2006/main" lIns="0" tIns="0" rIns="0" bIns="0" anchor="ctr"/>
+          <a:lstStyle xmlns:a="http://schemas.openxmlformats.org/drawingml/2006/main"/>
+          <a:p xmlns:a="http://schemas.openxmlformats.org/drawingml/2006/main">
+            <a:pPr algn="ctr">
+              <a:buNone/>
+            </a:pPr>
             <a:r>
               <a:rPr sz="1100" b="1">
                 <a:solidFill>
                   <a:srgbClr val="FF6677"/>
                 </a:solidFill>
                 <a:latin typeface="Helvetica Neue"/>
+                <a:ea typeface="Helvetica Neue"/>
+                <a:cs typeface="Helvetica Neue"/>
               </a:rPr>
               <a:t>⚠️ Recall Negative: 45,6% (đoán đúng 52 / 114 mẫu)</a:t>
             </a:r>

</xml_diff>